<commit_message>
Update and extend description of Kafka and KafkaStreams usage Fixes #1054
</commit_message>
<xml_diff>
--- a/doc/SharedComponents/Kafka/images/Kafka+KafkaStreams.pptx
+++ b/doc/SharedComponents/Kafka/images/Kafka+KafkaStreams.pptx
@@ -260,7 +260,7 @@
           <a:p>
             <a:fld id="{10552FEF-AD2B-419F-836B-7AC310F69A62}" type="datetimeFigureOut">
               <a:rPr lang="de-DE" smtClean="0"/>
-              <a:t>18.07.2025</a:t>
+              <a:t>22.07.2025</a:t>
             </a:fld>
             <a:endParaRPr lang="de-DE"/>
           </a:p>
@@ -458,7 +458,7 @@
           <a:p>
             <a:fld id="{10552FEF-AD2B-419F-836B-7AC310F69A62}" type="datetimeFigureOut">
               <a:rPr lang="de-DE" smtClean="0"/>
-              <a:t>18.07.2025</a:t>
+              <a:t>22.07.2025</a:t>
             </a:fld>
             <a:endParaRPr lang="de-DE"/>
           </a:p>
@@ -666,7 +666,7 @@
           <a:p>
             <a:fld id="{10552FEF-AD2B-419F-836B-7AC310F69A62}" type="datetimeFigureOut">
               <a:rPr lang="de-DE" smtClean="0"/>
-              <a:t>18.07.2025</a:t>
+              <a:t>22.07.2025</a:t>
             </a:fld>
             <a:endParaRPr lang="de-DE"/>
           </a:p>
@@ -864,7 +864,7 @@
           <a:p>
             <a:fld id="{10552FEF-AD2B-419F-836B-7AC310F69A62}" type="datetimeFigureOut">
               <a:rPr lang="de-DE" smtClean="0"/>
-              <a:t>18.07.2025</a:t>
+              <a:t>22.07.2025</a:t>
             </a:fld>
             <a:endParaRPr lang="de-DE"/>
           </a:p>
@@ -1139,7 +1139,7 @@
           <a:p>
             <a:fld id="{10552FEF-AD2B-419F-836B-7AC310F69A62}" type="datetimeFigureOut">
               <a:rPr lang="de-DE" smtClean="0"/>
-              <a:t>18.07.2025</a:t>
+              <a:t>22.07.2025</a:t>
             </a:fld>
             <a:endParaRPr lang="de-DE"/>
           </a:p>
@@ -1404,7 +1404,7 @@
           <a:p>
             <a:fld id="{10552FEF-AD2B-419F-836B-7AC310F69A62}" type="datetimeFigureOut">
               <a:rPr lang="de-DE" smtClean="0"/>
-              <a:t>18.07.2025</a:t>
+              <a:t>22.07.2025</a:t>
             </a:fld>
             <a:endParaRPr lang="de-DE"/>
           </a:p>
@@ -1816,7 +1816,7 @@
           <a:p>
             <a:fld id="{10552FEF-AD2B-419F-836B-7AC310F69A62}" type="datetimeFigureOut">
               <a:rPr lang="de-DE" smtClean="0"/>
-              <a:t>18.07.2025</a:t>
+              <a:t>22.07.2025</a:t>
             </a:fld>
             <a:endParaRPr lang="de-DE"/>
           </a:p>
@@ -1957,7 +1957,7 @@
           <a:p>
             <a:fld id="{10552FEF-AD2B-419F-836B-7AC310F69A62}" type="datetimeFigureOut">
               <a:rPr lang="de-DE" smtClean="0"/>
-              <a:t>18.07.2025</a:t>
+              <a:t>22.07.2025</a:t>
             </a:fld>
             <a:endParaRPr lang="de-DE"/>
           </a:p>
@@ -2070,7 +2070,7 @@
           <a:p>
             <a:fld id="{10552FEF-AD2B-419F-836B-7AC310F69A62}" type="datetimeFigureOut">
               <a:rPr lang="de-DE" smtClean="0"/>
-              <a:t>18.07.2025</a:t>
+              <a:t>22.07.2025</a:t>
             </a:fld>
             <a:endParaRPr lang="de-DE"/>
           </a:p>
@@ -2381,7 +2381,7 @@
           <a:p>
             <a:fld id="{10552FEF-AD2B-419F-836B-7AC310F69A62}" type="datetimeFigureOut">
               <a:rPr lang="de-DE" smtClean="0"/>
-              <a:t>18.07.2025</a:t>
+              <a:t>22.07.2025</a:t>
             </a:fld>
             <a:endParaRPr lang="de-DE"/>
           </a:p>
@@ -2669,7 +2669,7 @@
           <a:p>
             <a:fld id="{10552FEF-AD2B-419F-836B-7AC310F69A62}" type="datetimeFigureOut">
               <a:rPr lang="de-DE" smtClean="0"/>
-              <a:t>18.07.2025</a:t>
+              <a:t>22.07.2025</a:t>
             </a:fld>
             <a:endParaRPr lang="de-DE"/>
           </a:p>
@@ -2910,7 +2910,7 @@
           <a:p>
             <a:fld id="{10552FEF-AD2B-419F-836B-7AC310F69A62}" type="datetimeFigureOut">
               <a:rPr lang="de-DE" smtClean="0"/>
-              <a:t>18.07.2025</a:t>
+              <a:t>22.07.2025</a:t>
             </a:fld>
             <a:endParaRPr lang="de-DE"/>
           </a:p>
@@ -7626,6 +7626,55 @@
       </p:grpSpPr>
       <p:sp>
         <p:nvSpPr>
+          <p:cNvPr id="7" name="Rechteck 6">
+            <a:extLst>
+              <a:ext uri="{FF2B5EF4-FFF2-40B4-BE49-F238E27FC236}">
+                <a16:creationId xmlns:a16="http://schemas.microsoft.com/office/drawing/2014/main" id="{8DF172DF-F451-FBBF-15DE-CAF1A2FE1504}"/>
+              </a:ext>
+            </a:extLst>
+          </p:cNvPr>
+          <p:cNvSpPr/>
+          <p:nvPr/>
+        </p:nvSpPr>
+        <p:spPr>
+          <a:xfrm>
+            <a:off x="-1465943" y="-1451429"/>
+            <a:ext cx="13657943" cy="10072915"/>
+          </a:xfrm>
+          <a:prstGeom prst="rect">
+            <a:avLst/>
+          </a:prstGeom>
+          <a:solidFill>
+            <a:schemeClr val="bg1"/>
+          </a:solidFill>
+        </p:spPr>
+        <p:style>
+          <a:lnRef idx="2">
+            <a:schemeClr val="accent1">
+              <a:shade val="15000"/>
+            </a:schemeClr>
+          </a:lnRef>
+          <a:fillRef idx="1">
+            <a:schemeClr val="accent1"/>
+          </a:fillRef>
+          <a:effectRef idx="0">
+            <a:schemeClr val="accent1"/>
+          </a:effectRef>
+          <a:fontRef idx="minor">
+            <a:schemeClr val="lt1"/>
+          </a:fontRef>
+        </p:style>
+        <p:txBody>
+          <a:bodyPr rtlCol="0" anchor="ctr"/>
+          <a:lstStyle/>
+          <a:p>
+            <a:pPr algn="ctr"/>
+            <a:endParaRPr lang="de-DE"/>
+          </a:p>
+        </p:txBody>
+      </p:sp>
+      <p:sp>
+        <p:nvSpPr>
           <p:cNvPr id="4" name="Rechteck: abgerundete Ecken 3">
             <a:extLst>
               <a:ext uri="{FF2B5EF4-FFF2-40B4-BE49-F238E27FC236}">
@@ -7638,12 +7687,12 @@
         </p:nvSpPr>
         <p:spPr>
           <a:xfrm>
-            <a:off x="3197236" y="326765"/>
-            <a:ext cx="4751110" cy="4039495"/>
+            <a:off x="2401901" y="-418771"/>
+            <a:ext cx="4373421" cy="7719457"/>
           </a:xfrm>
           <a:prstGeom prst="roundRect">
             <a:avLst>
-              <a:gd name="adj" fmla="val 10715"/>
+              <a:gd name="adj" fmla="val 3689"/>
             </a:avLst>
           </a:prstGeom>
         </p:spPr>
@@ -7672,6 +7721,130 @@
       </p:sp>
       <p:sp>
         <p:nvSpPr>
+          <p:cNvPr id="1060" name="Rechteck: abgerundete Ecken 1059">
+            <a:extLst>
+              <a:ext uri="{FF2B5EF4-FFF2-40B4-BE49-F238E27FC236}">
+                <a16:creationId xmlns:a16="http://schemas.microsoft.com/office/drawing/2014/main" id="{7EAAB259-DF0A-6A2C-B07C-20E357FB5F74}"/>
+              </a:ext>
+            </a:extLst>
+          </p:cNvPr>
+          <p:cNvSpPr/>
+          <p:nvPr/>
+        </p:nvSpPr>
+        <p:spPr>
+          <a:xfrm>
+            <a:off x="7579000" y="5224919"/>
+            <a:ext cx="2235067" cy="1829259"/>
+          </a:xfrm>
+          <a:prstGeom prst="roundRect">
+            <a:avLst>
+              <a:gd name="adj" fmla="val 9662"/>
+            </a:avLst>
+          </a:prstGeom>
+          <a:solidFill>
+            <a:schemeClr val="tx2">
+              <a:lumMod val="10000"/>
+              <a:lumOff val="90000"/>
+            </a:schemeClr>
+          </a:solidFill>
+          <a:ln w="9525"/>
+        </p:spPr>
+        <p:style>
+          <a:lnRef idx="2">
+            <a:schemeClr val="accent1">
+              <a:shade val="15000"/>
+            </a:schemeClr>
+          </a:lnRef>
+          <a:fillRef idx="1">
+            <a:schemeClr val="accent1"/>
+          </a:fillRef>
+          <a:effectRef idx="0">
+            <a:schemeClr val="accent1"/>
+          </a:effectRef>
+          <a:fontRef idx="minor">
+            <a:schemeClr val="lt1"/>
+          </a:fontRef>
+        </p:style>
+        <p:txBody>
+          <a:bodyPr rtlCol="0" anchor="ctr"/>
+          <a:lstStyle/>
+          <a:p>
+            <a:pPr algn="ctr"/>
+            <a:endParaRPr lang="de-DE" sz="1000">
+              <a:solidFill>
+                <a:schemeClr val="tx1">
+                  <a:lumMod val="95000"/>
+                  <a:lumOff val="5000"/>
+                </a:schemeClr>
+              </a:solidFill>
+            </a:endParaRPr>
+          </a:p>
+        </p:txBody>
+      </p:sp>
+      <p:sp>
+        <p:nvSpPr>
+          <p:cNvPr id="1058" name="Rechteck: abgerundete Ecken 1057">
+            <a:extLst>
+              <a:ext uri="{FF2B5EF4-FFF2-40B4-BE49-F238E27FC236}">
+                <a16:creationId xmlns:a16="http://schemas.microsoft.com/office/drawing/2014/main" id="{7DE8BCAD-A743-5967-9C0F-ADB9C8288879}"/>
+              </a:ext>
+            </a:extLst>
+          </p:cNvPr>
+          <p:cNvSpPr/>
+          <p:nvPr/>
+        </p:nvSpPr>
+        <p:spPr>
+          <a:xfrm>
+            <a:off x="7566227" y="381906"/>
+            <a:ext cx="2235067" cy="4598283"/>
+          </a:xfrm>
+          <a:prstGeom prst="roundRect">
+            <a:avLst>
+              <a:gd name="adj" fmla="val 9662"/>
+            </a:avLst>
+          </a:prstGeom>
+          <a:solidFill>
+            <a:schemeClr val="tx2">
+              <a:lumMod val="10000"/>
+              <a:lumOff val="90000"/>
+            </a:schemeClr>
+          </a:solidFill>
+          <a:ln w="9525"/>
+        </p:spPr>
+        <p:style>
+          <a:lnRef idx="2">
+            <a:schemeClr val="accent1">
+              <a:shade val="15000"/>
+            </a:schemeClr>
+          </a:lnRef>
+          <a:fillRef idx="1">
+            <a:schemeClr val="accent1"/>
+          </a:fillRef>
+          <a:effectRef idx="0">
+            <a:schemeClr val="accent1"/>
+          </a:effectRef>
+          <a:fontRef idx="minor">
+            <a:schemeClr val="lt1"/>
+          </a:fontRef>
+        </p:style>
+        <p:txBody>
+          <a:bodyPr rtlCol="0" anchor="ctr"/>
+          <a:lstStyle/>
+          <a:p>
+            <a:pPr algn="ctr"/>
+            <a:endParaRPr lang="de-DE" sz="1000">
+              <a:solidFill>
+                <a:schemeClr val="tx1">
+                  <a:lumMod val="95000"/>
+                  <a:lumOff val="5000"/>
+                </a:schemeClr>
+              </a:solidFill>
+            </a:endParaRPr>
+          </a:p>
+        </p:txBody>
+      </p:sp>
+      <p:sp>
+        <p:nvSpPr>
           <p:cNvPr id="5" name="Textfeld 4">
             <a:extLst>
               <a:ext uri="{FF2B5EF4-FFF2-40B4-BE49-F238E27FC236}">
@@ -7684,8 +7857,8 @@
         </p:nvSpPr>
         <p:spPr>
           <a:xfrm>
-            <a:off x="4564459" y="468703"/>
-            <a:ext cx="1897615" cy="338554"/>
+            <a:off x="3489763" y="-350167"/>
+            <a:ext cx="1897615" cy="400110"/>
           </a:xfrm>
           <a:prstGeom prst="rect">
             <a:avLst/>
@@ -7700,7 +7873,7 @@
           <a:p>
             <a:pPr algn="ctr"/>
             <a:r>
-              <a:rPr lang="de-DE" sz="1600" b="1">
+              <a:rPr lang="de-DE" sz="2000" b="1">
                 <a:solidFill>
                   <a:schemeClr val="tx1">
                     <a:lumMod val="95000"/>
@@ -7727,655 +7900,13 @@
         </p:nvSpPr>
         <p:spPr>
           <a:xfrm>
-            <a:off x="3701908" y="1037506"/>
-            <a:ext cx="3622719" cy="866708"/>
+            <a:off x="2508590" y="381907"/>
+            <a:ext cx="4100277" cy="4598283"/>
           </a:xfrm>
           <a:prstGeom prst="roundRect">
-            <a:avLst/>
-          </a:prstGeom>
-          <a:solidFill>
-            <a:schemeClr val="bg1"/>
-          </a:solidFill>
-          <a:ln w="9525"/>
-        </p:spPr>
-        <p:style>
-          <a:lnRef idx="2">
-            <a:schemeClr val="accent1">
-              <a:shade val="15000"/>
-            </a:schemeClr>
-          </a:lnRef>
-          <a:fillRef idx="1">
-            <a:schemeClr val="accent1"/>
-          </a:fillRef>
-          <a:effectRef idx="0">
-            <a:schemeClr val="accent1"/>
-          </a:effectRef>
-          <a:fontRef idx="minor">
-            <a:schemeClr val="lt1"/>
-          </a:fontRef>
-        </p:style>
-        <p:txBody>
-          <a:bodyPr rtlCol="0" anchor="ctr"/>
-          <a:lstStyle/>
-          <a:p>
-            <a:pPr algn="ctr"/>
-            <a:endParaRPr lang="de-DE" sz="1000">
-              <a:solidFill>
-                <a:schemeClr val="tx1">
-                  <a:lumMod val="95000"/>
-                  <a:lumOff val="5000"/>
-                </a:schemeClr>
-              </a:solidFill>
-            </a:endParaRPr>
-          </a:p>
-        </p:txBody>
-      </p:sp>
-      <p:sp>
-        <p:nvSpPr>
-          <p:cNvPr id="25" name="Textfeld 24">
-            <a:extLst>
-              <a:ext uri="{FF2B5EF4-FFF2-40B4-BE49-F238E27FC236}">
-                <a16:creationId xmlns:a16="http://schemas.microsoft.com/office/drawing/2014/main" id="{5ECC5645-F8B8-DF06-9EAE-63AF3DA6E245}"/>
-              </a:ext>
-            </a:extLst>
-          </p:cNvPr>
-          <p:cNvSpPr txBox="1"/>
-          <p:nvPr/>
-        </p:nvSpPr>
-        <p:spPr>
-          <a:xfrm>
-            <a:off x="3780149" y="1310609"/>
-            <a:ext cx="740074" cy="369332"/>
-          </a:xfrm>
-          <a:prstGeom prst="rect">
-            <a:avLst/>
-          </a:prstGeom>
-          <a:noFill/>
-        </p:spPr>
-        <p:txBody>
-          <a:bodyPr wrap="none" rtlCol="0">
-            <a:spAutoFit/>
-          </a:bodyPr>
-          <a:lstStyle/>
-          <a:p>
-            <a:r>
-              <a:rPr lang="de-DE" b="1"/>
-              <a:t>Topic</a:t>
-            </a:r>
-          </a:p>
-        </p:txBody>
-      </p:sp>
-      <p:sp>
-        <p:nvSpPr>
-          <p:cNvPr id="32" name="Rechteck: abgerundete Ecken 31">
-            <a:extLst>
-              <a:ext uri="{FF2B5EF4-FFF2-40B4-BE49-F238E27FC236}">
-                <a16:creationId xmlns:a16="http://schemas.microsoft.com/office/drawing/2014/main" id="{78F14BC6-4403-D4BE-BB94-117EEC65D79D}"/>
-              </a:ext>
-            </a:extLst>
-          </p:cNvPr>
-          <p:cNvSpPr/>
-          <p:nvPr/>
-        </p:nvSpPr>
-        <p:spPr>
-          <a:xfrm>
-            <a:off x="6295665" y="1172512"/>
-            <a:ext cx="755076" cy="589130"/>
-          </a:xfrm>
-          <a:prstGeom prst="roundRect">
-            <a:avLst/>
-          </a:prstGeom>
-        </p:spPr>
-        <p:style>
-          <a:lnRef idx="1">
-            <a:schemeClr val="accent5"/>
-          </a:lnRef>
-          <a:fillRef idx="2">
-            <a:schemeClr val="accent5"/>
-          </a:fillRef>
-          <a:effectRef idx="1">
-            <a:schemeClr val="accent5"/>
-          </a:effectRef>
-          <a:fontRef idx="minor">
-            <a:schemeClr val="dk1"/>
-          </a:fontRef>
-        </p:style>
-        <p:txBody>
-          <a:bodyPr rtlCol="0" anchor="ctr"/>
-          <a:lstStyle/>
-          <a:p>
-            <a:pPr algn="ctr"/>
-            <a:endParaRPr lang="de-DE"/>
-          </a:p>
-        </p:txBody>
-      </p:sp>
-      <p:sp>
-        <p:nvSpPr>
-          <p:cNvPr id="33" name="Rechteck: abgerundete Ecken 32">
-            <a:extLst>
-              <a:ext uri="{FF2B5EF4-FFF2-40B4-BE49-F238E27FC236}">
-                <a16:creationId xmlns:a16="http://schemas.microsoft.com/office/drawing/2014/main" id="{41F43E79-1E21-56C9-2BA9-0CF3A0740E5B}"/>
-              </a:ext>
-            </a:extLst>
-          </p:cNvPr>
-          <p:cNvSpPr/>
-          <p:nvPr/>
-        </p:nvSpPr>
-        <p:spPr>
-          <a:xfrm>
-            <a:off x="3701908" y="2080818"/>
-            <a:ext cx="3622719" cy="866708"/>
-          </a:xfrm>
-          <a:prstGeom prst="roundRect">
-            <a:avLst/>
-          </a:prstGeom>
-          <a:solidFill>
-            <a:schemeClr val="bg1"/>
-          </a:solidFill>
-          <a:ln w="9525"/>
-        </p:spPr>
-        <p:style>
-          <a:lnRef idx="2">
-            <a:schemeClr val="accent1">
-              <a:shade val="15000"/>
-            </a:schemeClr>
-          </a:lnRef>
-          <a:fillRef idx="1">
-            <a:schemeClr val="accent1"/>
-          </a:fillRef>
-          <a:effectRef idx="0">
-            <a:schemeClr val="accent1"/>
-          </a:effectRef>
-          <a:fontRef idx="minor">
-            <a:schemeClr val="lt1"/>
-          </a:fontRef>
-        </p:style>
-        <p:txBody>
-          <a:bodyPr rtlCol="0" anchor="ctr"/>
-          <a:lstStyle/>
-          <a:p>
-            <a:pPr algn="ctr"/>
-            <a:endParaRPr lang="de-DE" sz="1000">
-              <a:solidFill>
-                <a:schemeClr val="tx1">
-                  <a:lumMod val="95000"/>
-                  <a:lumOff val="5000"/>
-                </a:schemeClr>
-              </a:solidFill>
-            </a:endParaRPr>
-          </a:p>
-        </p:txBody>
-      </p:sp>
-      <p:sp>
-        <p:nvSpPr>
-          <p:cNvPr id="34" name="Textfeld 33">
-            <a:extLst>
-              <a:ext uri="{FF2B5EF4-FFF2-40B4-BE49-F238E27FC236}">
-                <a16:creationId xmlns:a16="http://schemas.microsoft.com/office/drawing/2014/main" id="{14233CF3-2DC2-5159-8CB9-2623CFA983BE}"/>
-              </a:ext>
-            </a:extLst>
-          </p:cNvPr>
-          <p:cNvSpPr txBox="1"/>
-          <p:nvPr/>
-        </p:nvSpPr>
-        <p:spPr>
-          <a:xfrm>
-            <a:off x="3780149" y="2353921"/>
-            <a:ext cx="740074" cy="369332"/>
-          </a:xfrm>
-          <a:prstGeom prst="rect">
-            <a:avLst/>
-          </a:prstGeom>
-          <a:noFill/>
-        </p:spPr>
-        <p:txBody>
-          <a:bodyPr wrap="none" rtlCol="0">
-            <a:spAutoFit/>
-          </a:bodyPr>
-          <a:lstStyle/>
-          <a:p>
-            <a:r>
-              <a:rPr lang="de-DE" b="1"/>
-              <a:t>Topic</a:t>
-            </a:r>
-          </a:p>
-        </p:txBody>
-      </p:sp>
-      <p:sp>
-        <p:nvSpPr>
-          <p:cNvPr id="39" name="Rechteck: abgerundete Ecken 38">
-            <a:extLst>
-              <a:ext uri="{FF2B5EF4-FFF2-40B4-BE49-F238E27FC236}">
-                <a16:creationId xmlns:a16="http://schemas.microsoft.com/office/drawing/2014/main" id="{9F64F194-E194-3A8A-2533-3BC7D3A99B02}"/>
-              </a:ext>
-            </a:extLst>
-          </p:cNvPr>
-          <p:cNvSpPr/>
-          <p:nvPr/>
-        </p:nvSpPr>
-        <p:spPr>
-          <a:xfrm>
-            <a:off x="3701908" y="3182556"/>
-            <a:ext cx="3622719" cy="866708"/>
-          </a:xfrm>
-          <a:prstGeom prst="roundRect">
-            <a:avLst/>
-          </a:prstGeom>
-          <a:solidFill>
-            <a:schemeClr val="bg1"/>
-          </a:solidFill>
-          <a:ln w="9525"/>
-        </p:spPr>
-        <p:style>
-          <a:lnRef idx="2">
-            <a:schemeClr val="accent1">
-              <a:shade val="15000"/>
-            </a:schemeClr>
-          </a:lnRef>
-          <a:fillRef idx="1">
-            <a:schemeClr val="accent1"/>
-          </a:fillRef>
-          <a:effectRef idx="0">
-            <a:schemeClr val="accent1"/>
-          </a:effectRef>
-          <a:fontRef idx="minor">
-            <a:schemeClr val="lt1"/>
-          </a:fontRef>
-        </p:style>
-        <p:txBody>
-          <a:bodyPr rtlCol="0" anchor="ctr"/>
-          <a:lstStyle/>
-          <a:p>
-            <a:pPr algn="ctr"/>
-            <a:endParaRPr lang="de-DE" sz="1000">
-              <a:solidFill>
-                <a:schemeClr val="tx1">
-                  <a:lumMod val="95000"/>
-                  <a:lumOff val="5000"/>
-                </a:schemeClr>
-              </a:solidFill>
-            </a:endParaRPr>
-          </a:p>
-        </p:txBody>
-      </p:sp>
-      <p:sp>
-        <p:nvSpPr>
-          <p:cNvPr id="40" name="Textfeld 39">
-            <a:extLst>
-              <a:ext uri="{FF2B5EF4-FFF2-40B4-BE49-F238E27FC236}">
-                <a16:creationId xmlns:a16="http://schemas.microsoft.com/office/drawing/2014/main" id="{06A2D4FE-0902-4665-A699-A16400A89170}"/>
-              </a:ext>
-            </a:extLst>
-          </p:cNvPr>
-          <p:cNvSpPr txBox="1"/>
-          <p:nvPr/>
-        </p:nvSpPr>
-        <p:spPr>
-          <a:xfrm>
-            <a:off x="3780149" y="3455659"/>
-            <a:ext cx="740074" cy="369332"/>
-          </a:xfrm>
-          <a:prstGeom prst="rect">
-            <a:avLst/>
-          </a:prstGeom>
-          <a:noFill/>
-        </p:spPr>
-        <p:txBody>
-          <a:bodyPr wrap="none" rtlCol="0">
-            <a:spAutoFit/>
-          </a:bodyPr>
-          <a:lstStyle/>
-          <a:p>
-            <a:r>
-              <a:rPr lang="de-DE" b="1"/>
-              <a:t>Topic</a:t>
-            </a:r>
-          </a:p>
-        </p:txBody>
-      </p:sp>
-      <p:sp>
-        <p:nvSpPr>
-          <p:cNvPr id="47" name="Rechteck: abgerundete Ecken 46">
-            <a:extLst>
-              <a:ext uri="{FF2B5EF4-FFF2-40B4-BE49-F238E27FC236}">
-                <a16:creationId xmlns:a16="http://schemas.microsoft.com/office/drawing/2014/main" id="{B3201942-2006-31F2-B64A-997E258372A0}"/>
-              </a:ext>
-            </a:extLst>
-          </p:cNvPr>
-          <p:cNvSpPr/>
-          <p:nvPr/>
-        </p:nvSpPr>
-        <p:spPr>
-          <a:xfrm>
-            <a:off x="669758" y="2601829"/>
-            <a:ext cx="1284772" cy="413815"/>
-          </a:xfrm>
-          <a:prstGeom prst="roundRect">
-            <a:avLst/>
-          </a:prstGeom>
-        </p:spPr>
-        <p:style>
-          <a:lnRef idx="1">
-            <a:schemeClr val="accent4"/>
-          </a:lnRef>
-          <a:fillRef idx="2">
-            <a:schemeClr val="accent4"/>
-          </a:fillRef>
-          <a:effectRef idx="1">
-            <a:schemeClr val="accent4"/>
-          </a:effectRef>
-          <a:fontRef idx="minor">
-            <a:schemeClr val="dk1"/>
-          </a:fontRef>
-        </p:style>
-        <p:txBody>
-          <a:bodyPr rtlCol="0" anchor="ctr"/>
-          <a:lstStyle/>
-          <a:p>
-            <a:pPr algn="ctr"/>
-            <a:r>
-              <a:rPr lang="de-DE" sz="1400" b="1">
-                <a:solidFill>
-                  <a:schemeClr val="dk1"/>
-                </a:solidFill>
-              </a:rPr>
-              <a:t>Producer</a:t>
-            </a:r>
-            <a:endParaRPr lang="de-DE" sz="900">
-              <a:solidFill>
-                <a:schemeClr val="dk1"/>
-              </a:solidFill>
-            </a:endParaRPr>
-          </a:p>
-        </p:txBody>
-      </p:sp>
-      <p:sp>
-        <p:nvSpPr>
-          <p:cNvPr id="48" name="Rechteck: abgerundete Ecken 47">
-            <a:extLst>
-              <a:ext uri="{FF2B5EF4-FFF2-40B4-BE49-F238E27FC236}">
-                <a16:creationId xmlns:a16="http://schemas.microsoft.com/office/drawing/2014/main" id="{43A090A3-AF1B-596C-E204-22A8CB5F15C0}"/>
-              </a:ext>
-            </a:extLst>
-          </p:cNvPr>
-          <p:cNvSpPr/>
-          <p:nvPr/>
-        </p:nvSpPr>
-        <p:spPr>
-          <a:xfrm>
-            <a:off x="668811" y="3411459"/>
-            <a:ext cx="1285719" cy="413815"/>
-          </a:xfrm>
-          <a:prstGeom prst="roundRect">
-            <a:avLst/>
-          </a:prstGeom>
-        </p:spPr>
-        <p:style>
-          <a:lnRef idx="1">
-            <a:schemeClr val="accent6"/>
-          </a:lnRef>
-          <a:fillRef idx="2">
-            <a:schemeClr val="accent6"/>
-          </a:fillRef>
-          <a:effectRef idx="1">
-            <a:schemeClr val="accent6"/>
-          </a:effectRef>
-          <a:fontRef idx="minor">
-            <a:schemeClr val="dk1"/>
-          </a:fontRef>
-        </p:style>
-        <p:txBody>
-          <a:bodyPr rtlCol="0" anchor="ctr"/>
-          <a:lstStyle/>
-          <a:p>
-            <a:pPr algn="ctr"/>
-            <a:r>
-              <a:rPr lang="de-DE" sz="1400" b="1"/>
-              <a:t>Consumer</a:t>
-            </a:r>
-            <a:endParaRPr lang="de-DE" sz="900"/>
-          </a:p>
-        </p:txBody>
-      </p:sp>
-      <p:sp>
-        <p:nvSpPr>
-          <p:cNvPr id="49" name="Rechteck: abgerundete Ecken 48">
-            <a:extLst>
-              <a:ext uri="{FF2B5EF4-FFF2-40B4-BE49-F238E27FC236}">
-                <a16:creationId xmlns:a16="http://schemas.microsoft.com/office/drawing/2014/main" id="{7B39F083-73D2-28F8-0F19-1A42D1E20C56}"/>
-              </a:ext>
-            </a:extLst>
-          </p:cNvPr>
-          <p:cNvSpPr/>
-          <p:nvPr/>
-        </p:nvSpPr>
-        <p:spPr>
-          <a:xfrm>
-            <a:off x="4621249" y="1172512"/>
-            <a:ext cx="755076" cy="589130"/>
-          </a:xfrm>
-          <a:prstGeom prst="roundRect">
-            <a:avLst/>
-          </a:prstGeom>
-        </p:spPr>
-        <p:style>
-          <a:lnRef idx="1">
-            <a:schemeClr val="accent5"/>
-          </a:lnRef>
-          <a:fillRef idx="2">
-            <a:schemeClr val="accent5"/>
-          </a:fillRef>
-          <a:effectRef idx="1">
-            <a:schemeClr val="accent5"/>
-          </a:effectRef>
-          <a:fontRef idx="minor">
-            <a:schemeClr val="dk1"/>
-          </a:fontRef>
-        </p:style>
-        <p:txBody>
-          <a:bodyPr rtlCol="0" anchor="ctr"/>
-          <a:lstStyle/>
-          <a:p>
-            <a:pPr algn="ctr"/>
-            <a:endParaRPr lang="de-DE"/>
-          </a:p>
-        </p:txBody>
-      </p:sp>
-      <p:sp>
-        <p:nvSpPr>
-          <p:cNvPr id="50" name="Rechteck: abgerundete Ecken 49">
-            <a:extLst>
-              <a:ext uri="{FF2B5EF4-FFF2-40B4-BE49-F238E27FC236}">
-                <a16:creationId xmlns:a16="http://schemas.microsoft.com/office/drawing/2014/main" id="{605AF275-F4FF-EFB8-6DF5-F3A60691B823}"/>
-              </a:ext>
-            </a:extLst>
-          </p:cNvPr>
-          <p:cNvSpPr/>
-          <p:nvPr/>
-        </p:nvSpPr>
-        <p:spPr>
-          <a:xfrm>
-            <a:off x="5466744" y="1172512"/>
-            <a:ext cx="755076" cy="589130"/>
-          </a:xfrm>
-          <a:prstGeom prst="roundRect">
-            <a:avLst/>
-          </a:prstGeom>
-        </p:spPr>
-        <p:style>
-          <a:lnRef idx="1">
-            <a:schemeClr val="accent5"/>
-          </a:lnRef>
-          <a:fillRef idx="2">
-            <a:schemeClr val="accent5"/>
-          </a:fillRef>
-          <a:effectRef idx="1">
-            <a:schemeClr val="accent5"/>
-          </a:effectRef>
-          <a:fontRef idx="minor">
-            <a:schemeClr val="dk1"/>
-          </a:fontRef>
-        </p:style>
-        <p:txBody>
-          <a:bodyPr rtlCol="0" anchor="ctr"/>
-          <a:lstStyle/>
-          <a:p>
-            <a:pPr algn="ctr"/>
-            <a:endParaRPr lang="de-DE"/>
-          </a:p>
-        </p:txBody>
-      </p:sp>
-      <p:sp>
-        <p:nvSpPr>
-          <p:cNvPr id="52" name="Rechteck: abgerundete Ecken 51">
-            <a:extLst>
-              <a:ext uri="{FF2B5EF4-FFF2-40B4-BE49-F238E27FC236}">
-                <a16:creationId xmlns:a16="http://schemas.microsoft.com/office/drawing/2014/main" id="{49A98462-E671-66C6-DBA9-6FB9A97FA2A9}"/>
-              </a:ext>
-            </a:extLst>
-          </p:cNvPr>
-          <p:cNvSpPr/>
-          <p:nvPr/>
-        </p:nvSpPr>
-        <p:spPr>
-          <a:xfrm>
-            <a:off x="4621249" y="2212263"/>
-            <a:ext cx="755076" cy="589130"/>
-          </a:xfrm>
-          <a:prstGeom prst="roundRect">
-            <a:avLst/>
-          </a:prstGeom>
-        </p:spPr>
-        <p:style>
-          <a:lnRef idx="1">
-            <a:schemeClr val="accent2"/>
-          </a:lnRef>
-          <a:fillRef idx="2">
-            <a:schemeClr val="accent2"/>
-          </a:fillRef>
-          <a:effectRef idx="1">
-            <a:schemeClr val="accent2"/>
-          </a:effectRef>
-          <a:fontRef idx="minor">
-            <a:schemeClr val="dk1"/>
-          </a:fontRef>
-        </p:style>
-        <p:txBody>
-          <a:bodyPr rtlCol="0" anchor="ctr"/>
-          <a:lstStyle/>
-          <a:p>
-            <a:pPr algn="ctr"/>
-            <a:endParaRPr lang="de-DE"/>
-          </a:p>
-        </p:txBody>
-      </p:sp>
-      <p:sp>
-        <p:nvSpPr>
-          <p:cNvPr id="53" name="Rechteck: abgerundete Ecken 52">
-            <a:extLst>
-              <a:ext uri="{FF2B5EF4-FFF2-40B4-BE49-F238E27FC236}">
-                <a16:creationId xmlns:a16="http://schemas.microsoft.com/office/drawing/2014/main" id="{07C8DBFE-F5C5-E238-C5F1-08E754A92EF3}"/>
-              </a:ext>
-            </a:extLst>
-          </p:cNvPr>
-          <p:cNvSpPr/>
-          <p:nvPr/>
-        </p:nvSpPr>
-        <p:spPr>
-          <a:xfrm>
-            <a:off x="5466744" y="2219607"/>
-            <a:ext cx="755076" cy="589130"/>
-          </a:xfrm>
-          <a:prstGeom prst="roundRect">
-            <a:avLst/>
-          </a:prstGeom>
-        </p:spPr>
-        <p:style>
-          <a:lnRef idx="1">
-            <a:schemeClr val="accent2"/>
-          </a:lnRef>
-          <a:fillRef idx="2">
-            <a:schemeClr val="accent2"/>
-          </a:fillRef>
-          <a:effectRef idx="1">
-            <a:schemeClr val="accent2"/>
-          </a:effectRef>
-          <a:fontRef idx="minor">
-            <a:schemeClr val="dk1"/>
-          </a:fontRef>
-        </p:style>
-        <p:txBody>
-          <a:bodyPr rtlCol="0" anchor="ctr"/>
-          <a:lstStyle/>
-          <a:p>
-            <a:pPr algn="ctr"/>
-            <a:endParaRPr lang="de-DE"/>
-          </a:p>
-        </p:txBody>
-      </p:sp>
-      <p:sp>
-        <p:nvSpPr>
-          <p:cNvPr id="54" name="Rechteck: abgerundete Ecken 53">
-            <a:extLst>
-              <a:ext uri="{FF2B5EF4-FFF2-40B4-BE49-F238E27FC236}">
-                <a16:creationId xmlns:a16="http://schemas.microsoft.com/office/drawing/2014/main" id="{A15B3C0D-18E3-BDA2-423C-518D2834469E}"/>
-              </a:ext>
-            </a:extLst>
-          </p:cNvPr>
-          <p:cNvSpPr/>
-          <p:nvPr/>
-        </p:nvSpPr>
-        <p:spPr>
-          <a:xfrm>
-            <a:off x="6325289" y="2202762"/>
-            <a:ext cx="755076" cy="589130"/>
-          </a:xfrm>
-          <a:prstGeom prst="roundRect">
-            <a:avLst/>
-          </a:prstGeom>
-        </p:spPr>
-        <p:style>
-          <a:lnRef idx="1">
-            <a:schemeClr val="accent2"/>
-          </a:lnRef>
-          <a:fillRef idx="2">
-            <a:schemeClr val="accent2"/>
-          </a:fillRef>
-          <a:effectRef idx="1">
-            <a:schemeClr val="accent2"/>
-          </a:effectRef>
-          <a:fontRef idx="minor">
-            <a:schemeClr val="dk1"/>
-          </a:fontRef>
-        </p:style>
-        <p:txBody>
-          <a:bodyPr rtlCol="0" anchor="ctr"/>
-          <a:lstStyle/>
-          <a:p>
-            <a:pPr algn="ctr"/>
-            <a:endParaRPr lang="de-DE"/>
-          </a:p>
-        </p:txBody>
-      </p:sp>
-      <p:sp>
-        <p:nvSpPr>
-          <p:cNvPr id="55" name="Rechteck: abgerundete Ecken 54">
-            <a:extLst>
-              <a:ext uri="{FF2B5EF4-FFF2-40B4-BE49-F238E27FC236}">
-                <a16:creationId xmlns:a16="http://schemas.microsoft.com/office/drawing/2014/main" id="{E6297B38-BFD4-2D9C-1DC1-E1F45E7B72A7}"/>
-              </a:ext>
-            </a:extLst>
-          </p:cNvPr>
-          <p:cNvSpPr/>
-          <p:nvPr/>
-        </p:nvSpPr>
-        <p:spPr>
-          <a:xfrm>
-            <a:off x="4606840" y="3322995"/>
-            <a:ext cx="755076" cy="589130"/>
-          </a:xfrm>
-          <a:prstGeom prst="roundRect">
-            <a:avLst/>
+            <a:avLst>
+              <a:gd name="adj" fmla="val 9662"/>
+            </a:avLst>
           </a:prstGeom>
           <a:gradFill>
             <a:gsLst>
@@ -8415,16 +7946,851 @@
           <a:lstStyle/>
           <a:p>
             <a:pPr algn="ctr"/>
+            <a:endParaRPr lang="de-DE">
+              <a:solidFill>
+                <a:schemeClr val="dk1"/>
+              </a:solidFill>
+            </a:endParaRPr>
+          </a:p>
+        </p:txBody>
+      </p:sp>
+      <p:sp>
+        <p:nvSpPr>
+          <p:cNvPr id="25" name="Textfeld 24">
+            <a:extLst>
+              <a:ext uri="{FF2B5EF4-FFF2-40B4-BE49-F238E27FC236}">
+                <a16:creationId xmlns:a16="http://schemas.microsoft.com/office/drawing/2014/main" id="{5ECC5645-F8B8-DF06-9EAE-63AF3DA6E245}"/>
+              </a:ext>
+            </a:extLst>
+          </p:cNvPr>
+          <p:cNvSpPr txBox="1"/>
+          <p:nvPr/>
+        </p:nvSpPr>
+        <p:spPr>
+          <a:xfrm>
+            <a:off x="2817506" y="429011"/>
+            <a:ext cx="929229" cy="369332"/>
+          </a:xfrm>
+          <a:prstGeom prst="rect">
+            <a:avLst/>
+          </a:prstGeom>
+          <a:noFill/>
+        </p:spPr>
+        <p:txBody>
+          <a:bodyPr wrap="none" rtlCol="0">
+            <a:spAutoFit/>
+          </a:bodyPr>
+          <a:lstStyle/>
+          <a:p>
+            <a:r>
+              <a:rPr lang="de-DE" b="1"/>
+              <a:t>Topic A</a:t>
+            </a:r>
+          </a:p>
+        </p:txBody>
+      </p:sp>
+      <p:sp>
+        <p:nvSpPr>
+          <p:cNvPr id="33" name="Rechteck: abgerundete Ecken 32">
+            <a:extLst>
+              <a:ext uri="{FF2B5EF4-FFF2-40B4-BE49-F238E27FC236}">
+                <a16:creationId xmlns:a16="http://schemas.microsoft.com/office/drawing/2014/main" id="{41F43E79-1E21-56C9-2BA9-0CF3A0740E5B}"/>
+              </a:ext>
+            </a:extLst>
+          </p:cNvPr>
+          <p:cNvSpPr/>
+          <p:nvPr/>
+        </p:nvSpPr>
+        <p:spPr>
+          <a:xfrm>
+            <a:off x="2817506" y="1199725"/>
+            <a:ext cx="3622719" cy="866708"/>
+          </a:xfrm>
+          <a:prstGeom prst="roundRect">
+            <a:avLst/>
+          </a:prstGeom>
+          <a:solidFill>
+            <a:schemeClr val="bg1"/>
+          </a:solidFill>
+          <a:ln w="9525"/>
+        </p:spPr>
+        <p:style>
+          <a:lnRef idx="2">
+            <a:schemeClr val="accent1">
+              <a:shade val="15000"/>
+            </a:schemeClr>
+          </a:lnRef>
+          <a:fillRef idx="1">
+            <a:schemeClr val="accent1"/>
+          </a:fillRef>
+          <a:effectRef idx="0">
+            <a:schemeClr val="accent1"/>
+          </a:effectRef>
+          <a:fontRef idx="minor">
+            <a:schemeClr val="lt1"/>
+          </a:fontRef>
+        </p:style>
+        <p:txBody>
+          <a:bodyPr rtlCol="0" anchor="ctr"/>
+          <a:lstStyle/>
+          <a:p>
+            <a:pPr algn="ctr"/>
+            <a:endParaRPr lang="de-DE" sz="1000">
+              <a:solidFill>
+                <a:schemeClr val="tx1">
+                  <a:lumMod val="95000"/>
+                  <a:lumOff val="5000"/>
+                </a:schemeClr>
+              </a:solidFill>
+            </a:endParaRPr>
+          </a:p>
+        </p:txBody>
+      </p:sp>
+      <p:sp>
+        <p:nvSpPr>
+          <p:cNvPr id="47" name="Rechteck: abgerundete Ecken 46">
+            <a:extLst>
+              <a:ext uri="{FF2B5EF4-FFF2-40B4-BE49-F238E27FC236}">
+                <a16:creationId xmlns:a16="http://schemas.microsoft.com/office/drawing/2014/main" id="{B3201942-2006-31F2-B64A-997E258372A0}"/>
+              </a:ext>
+            </a:extLst>
+          </p:cNvPr>
+          <p:cNvSpPr/>
+          <p:nvPr/>
+        </p:nvSpPr>
+        <p:spPr>
+          <a:xfrm>
+            <a:off x="217714" y="1426171"/>
+            <a:ext cx="1284772" cy="413815"/>
+          </a:xfrm>
+          <a:prstGeom prst="roundRect">
+            <a:avLst/>
+          </a:prstGeom>
+        </p:spPr>
+        <p:style>
+          <a:lnRef idx="1">
+            <a:schemeClr val="accent4"/>
+          </a:lnRef>
+          <a:fillRef idx="2">
+            <a:schemeClr val="accent4"/>
+          </a:fillRef>
+          <a:effectRef idx="1">
+            <a:schemeClr val="accent4"/>
+          </a:effectRef>
+          <a:fontRef idx="minor">
+            <a:schemeClr val="dk1"/>
+          </a:fontRef>
+        </p:style>
+        <p:txBody>
+          <a:bodyPr rtlCol="0" anchor="ctr"/>
+          <a:lstStyle/>
+          <a:p>
+            <a:pPr algn="ctr"/>
+            <a:r>
+              <a:rPr lang="de-DE" b="1">
+                <a:solidFill>
+                  <a:schemeClr val="dk1"/>
+                </a:solidFill>
+              </a:rPr>
+              <a:t>Producer</a:t>
+            </a:r>
+            <a:endParaRPr lang="de-DE" sz="1050">
+              <a:solidFill>
+                <a:schemeClr val="dk1"/>
+              </a:solidFill>
+            </a:endParaRPr>
+          </a:p>
+        </p:txBody>
+      </p:sp>
+      <p:sp>
+        <p:nvSpPr>
+          <p:cNvPr id="48" name="Rechteck: abgerundete Ecken 47">
+            <a:extLst>
+              <a:ext uri="{FF2B5EF4-FFF2-40B4-BE49-F238E27FC236}">
+                <a16:creationId xmlns:a16="http://schemas.microsoft.com/office/drawing/2014/main" id="{43A090A3-AF1B-596C-E204-22A8CB5F15C0}"/>
+              </a:ext>
+            </a:extLst>
+          </p:cNvPr>
+          <p:cNvSpPr/>
+          <p:nvPr/>
+        </p:nvSpPr>
+        <p:spPr>
+          <a:xfrm>
+            <a:off x="7875145" y="1322868"/>
+            <a:ext cx="1390483" cy="413815"/>
+          </a:xfrm>
+          <a:prstGeom prst="roundRect">
+            <a:avLst/>
+          </a:prstGeom>
+        </p:spPr>
+        <p:style>
+          <a:lnRef idx="1">
+            <a:schemeClr val="accent6"/>
+          </a:lnRef>
+          <a:fillRef idx="2">
+            <a:schemeClr val="accent6"/>
+          </a:fillRef>
+          <a:effectRef idx="1">
+            <a:schemeClr val="accent6"/>
+          </a:effectRef>
+          <a:fontRef idx="minor">
+            <a:schemeClr val="dk1"/>
+          </a:fontRef>
+        </p:style>
+        <p:txBody>
+          <a:bodyPr rtlCol="0" anchor="ctr"/>
+          <a:lstStyle/>
+          <a:p>
+            <a:pPr algn="ctr"/>
+            <a:r>
+              <a:rPr lang="de-DE" b="1"/>
+              <a:t>Consumer</a:t>
+            </a:r>
+            <a:endParaRPr lang="de-DE" sz="1050"/>
+          </a:p>
+        </p:txBody>
+      </p:sp>
+      <p:sp>
+        <p:nvSpPr>
+          <p:cNvPr id="50" name="Rechteck: abgerundete Ecken 49">
+            <a:extLst>
+              <a:ext uri="{FF2B5EF4-FFF2-40B4-BE49-F238E27FC236}">
+                <a16:creationId xmlns:a16="http://schemas.microsoft.com/office/drawing/2014/main" id="{605AF275-F4FF-EFB8-6DF5-F3A60691B823}"/>
+              </a:ext>
+            </a:extLst>
+          </p:cNvPr>
+          <p:cNvSpPr/>
+          <p:nvPr/>
+        </p:nvSpPr>
+        <p:spPr>
+          <a:xfrm>
+            <a:off x="3282120" y="1316144"/>
+            <a:ext cx="755076" cy="589130"/>
+          </a:xfrm>
+          <a:prstGeom prst="roundRect">
+            <a:avLst/>
+          </a:prstGeom>
+        </p:spPr>
+        <p:style>
+          <a:lnRef idx="1">
+            <a:schemeClr val="accent5"/>
+          </a:lnRef>
+          <a:fillRef idx="2">
+            <a:schemeClr val="accent5"/>
+          </a:fillRef>
+          <a:effectRef idx="1">
+            <a:schemeClr val="accent5"/>
+          </a:effectRef>
+          <a:fontRef idx="minor">
+            <a:schemeClr val="dk1"/>
+          </a:fontRef>
+        </p:style>
+        <p:txBody>
+          <a:bodyPr rtlCol="0" anchor="ctr"/>
+          <a:lstStyle/>
+          <a:p>
+            <a:pPr algn="ctr"/>
+            <a:r>
+              <a:rPr lang="de-DE"/>
+              <a:t>0</a:t>
+            </a:r>
+          </a:p>
+        </p:txBody>
+      </p:sp>
+      <p:sp>
+        <p:nvSpPr>
+          <p:cNvPr id="2" name="Textfeld 1">
+            <a:extLst>
+              <a:ext uri="{FF2B5EF4-FFF2-40B4-BE49-F238E27FC236}">
+                <a16:creationId xmlns:a16="http://schemas.microsoft.com/office/drawing/2014/main" id="{130B78AE-5B9E-1C73-25AF-4F1A17FE24F7}"/>
+              </a:ext>
+            </a:extLst>
+          </p:cNvPr>
+          <p:cNvSpPr txBox="1"/>
+          <p:nvPr/>
+        </p:nvSpPr>
+        <p:spPr>
+          <a:xfrm>
+            <a:off x="4058478" y="830393"/>
+            <a:ext cx="1083438" cy="338554"/>
+          </a:xfrm>
+          <a:prstGeom prst="rect">
+            <a:avLst/>
+          </a:prstGeom>
+          <a:noFill/>
+        </p:spPr>
+        <p:txBody>
+          <a:bodyPr wrap="none" rtlCol="0">
+            <a:spAutoFit/>
+          </a:bodyPr>
+          <a:lstStyle/>
+          <a:p>
+            <a:r>
+              <a:rPr lang="de-DE" sz="1600"/>
+              <a:t>Partition 1</a:t>
+            </a:r>
+          </a:p>
+        </p:txBody>
+      </p:sp>
+      <p:sp>
+        <p:nvSpPr>
+          <p:cNvPr id="3" name="Rechteck: abgerundete Ecken 2">
+            <a:extLst>
+              <a:ext uri="{FF2B5EF4-FFF2-40B4-BE49-F238E27FC236}">
+                <a16:creationId xmlns:a16="http://schemas.microsoft.com/office/drawing/2014/main" id="{1EEDC163-E8B8-20CB-9F8E-F102B3A55421}"/>
+              </a:ext>
+            </a:extLst>
+          </p:cNvPr>
+          <p:cNvSpPr/>
+          <p:nvPr/>
+        </p:nvSpPr>
+        <p:spPr>
+          <a:xfrm>
+            <a:off x="4222659" y="1322868"/>
+            <a:ext cx="755076" cy="589130"/>
+          </a:xfrm>
+          <a:prstGeom prst="roundRect">
+            <a:avLst/>
+          </a:prstGeom>
+        </p:spPr>
+        <p:style>
+          <a:lnRef idx="1">
+            <a:schemeClr val="accent5"/>
+          </a:lnRef>
+          <a:fillRef idx="2">
+            <a:schemeClr val="accent5"/>
+          </a:fillRef>
+          <a:effectRef idx="1">
+            <a:schemeClr val="accent5"/>
+          </a:effectRef>
+          <a:fontRef idx="minor">
+            <a:schemeClr val="dk1"/>
+          </a:fontRef>
+        </p:style>
+        <p:txBody>
+          <a:bodyPr rtlCol="0" anchor="ctr"/>
+          <a:lstStyle/>
+          <a:p>
+            <a:pPr algn="ctr"/>
+            <a:r>
+              <a:rPr lang="de-DE"/>
+              <a:t>1</a:t>
+            </a:r>
+          </a:p>
+        </p:txBody>
+      </p:sp>
+      <p:sp>
+        <p:nvSpPr>
+          <p:cNvPr id="6" name="Rechteck: abgerundete Ecken 5">
+            <a:extLst>
+              <a:ext uri="{FF2B5EF4-FFF2-40B4-BE49-F238E27FC236}">
+                <a16:creationId xmlns:a16="http://schemas.microsoft.com/office/drawing/2014/main" id="{3C5CB13C-3DAA-5C3A-21D7-9166391E74D1}"/>
+              </a:ext>
+            </a:extLst>
+          </p:cNvPr>
+          <p:cNvSpPr/>
+          <p:nvPr/>
+        </p:nvSpPr>
+        <p:spPr>
+          <a:xfrm>
+            <a:off x="5163198" y="1316144"/>
+            <a:ext cx="755076" cy="589130"/>
+          </a:xfrm>
+          <a:prstGeom prst="roundRect">
+            <a:avLst/>
+          </a:prstGeom>
+        </p:spPr>
+        <p:style>
+          <a:lnRef idx="1">
+            <a:schemeClr val="accent5"/>
+          </a:lnRef>
+          <a:fillRef idx="2">
+            <a:schemeClr val="accent5"/>
+          </a:fillRef>
+          <a:effectRef idx="1">
+            <a:schemeClr val="accent5"/>
+          </a:effectRef>
+          <a:fontRef idx="minor">
+            <a:schemeClr val="dk1"/>
+          </a:fontRef>
+        </p:style>
+        <p:txBody>
+          <a:bodyPr rtlCol="0" anchor="ctr"/>
+          <a:lstStyle/>
+          <a:p>
+            <a:pPr algn="ctr"/>
+            <a:r>
+              <a:rPr lang="de-DE"/>
+              <a:t>2</a:t>
+            </a:r>
+          </a:p>
+        </p:txBody>
+      </p:sp>
+      <p:sp>
+        <p:nvSpPr>
+          <p:cNvPr id="12" name="Rechteck: abgerundete Ecken 11">
+            <a:extLst>
+              <a:ext uri="{FF2B5EF4-FFF2-40B4-BE49-F238E27FC236}">
+                <a16:creationId xmlns:a16="http://schemas.microsoft.com/office/drawing/2014/main" id="{101B7ABF-B40C-5091-025A-8B851F9A4043}"/>
+              </a:ext>
+            </a:extLst>
+          </p:cNvPr>
+          <p:cNvSpPr/>
+          <p:nvPr/>
+        </p:nvSpPr>
+        <p:spPr>
+          <a:xfrm>
+            <a:off x="2807432" y="2496832"/>
+            <a:ext cx="3622719" cy="866708"/>
+          </a:xfrm>
+          <a:prstGeom prst="roundRect">
+            <a:avLst/>
+          </a:prstGeom>
+          <a:solidFill>
+            <a:schemeClr val="bg1"/>
+          </a:solidFill>
+          <a:ln w="9525"/>
+        </p:spPr>
+        <p:style>
+          <a:lnRef idx="2">
+            <a:schemeClr val="accent1">
+              <a:shade val="15000"/>
+            </a:schemeClr>
+          </a:lnRef>
+          <a:fillRef idx="1">
+            <a:schemeClr val="accent1"/>
+          </a:fillRef>
+          <a:effectRef idx="0">
+            <a:schemeClr val="accent1"/>
+          </a:effectRef>
+          <a:fontRef idx="minor">
+            <a:schemeClr val="lt1"/>
+          </a:fontRef>
+        </p:style>
+        <p:txBody>
+          <a:bodyPr rtlCol="0" anchor="ctr"/>
+          <a:lstStyle/>
+          <a:p>
+            <a:pPr algn="ctr"/>
+            <a:endParaRPr lang="de-DE" sz="1000">
+              <a:solidFill>
+                <a:schemeClr val="tx1">
+                  <a:lumMod val="95000"/>
+                  <a:lumOff val="5000"/>
+                </a:schemeClr>
+              </a:solidFill>
+            </a:endParaRPr>
+          </a:p>
+        </p:txBody>
+      </p:sp>
+      <p:sp>
+        <p:nvSpPr>
+          <p:cNvPr id="13" name="Rechteck: abgerundete Ecken 12">
+            <a:extLst>
+              <a:ext uri="{FF2B5EF4-FFF2-40B4-BE49-F238E27FC236}">
+                <a16:creationId xmlns:a16="http://schemas.microsoft.com/office/drawing/2014/main" id="{DA61E0FA-4661-5DF2-9F89-B49058A2DEF9}"/>
+              </a:ext>
+            </a:extLst>
+          </p:cNvPr>
+          <p:cNvSpPr/>
+          <p:nvPr/>
+        </p:nvSpPr>
+        <p:spPr>
+          <a:xfrm>
+            <a:off x="3272046" y="2613251"/>
+            <a:ext cx="755076" cy="589130"/>
+          </a:xfrm>
+          <a:prstGeom prst="roundRect">
+            <a:avLst/>
+          </a:prstGeom>
+        </p:spPr>
+        <p:style>
+          <a:lnRef idx="1">
+            <a:schemeClr val="accent5"/>
+          </a:lnRef>
+          <a:fillRef idx="2">
+            <a:schemeClr val="accent5"/>
+          </a:fillRef>
+          <a:effectRef idx="1">
+            <a:schemeClr val="accent5"/>
+          </a:effectRef>
+          <a:fontRef idx="minor">
+            <a:schemeClr val="dk1"/>
+          </a:fontRef>
+        </p:style>
+        <p:txBody>
+          <a:bodyPr rtlCol="0" anchor="ctr"/>
+          <a:lstStyle/>
+          <a:p>
+            <a:pPr algn="ctr"/>
+            <a:r>
+              <a:rPr lang="de-DE"/>
+              <a:t>0</a:t>
+            </a:r>
+          </a:p>
+        </p:txBody>
+      </p:sp>
+      <p:sp>
+        <p:nvSpPr>
+          <p:cNvPr id="14" name="Textfeld 13">
+            <a:extLst>
+              <a:ext uri="{FF2B5EF4-FFF2-40B4-BE49-F238E27FC236}">
+                <a16:creationId xmlns:a16="http://schemas.microsoft.com/office/drawing/2014/main" id="{E3FEC9D7-84E2-6488-A052-3FEA0BD6B799}"/>
+              </a:ext>
+            </a:extLst>
+          </p:cNvPr>
+          <p:cNvSpPr txBox="1"/>
+          <p:nvPr/>
+        </p:nvSpPr>
+        <p:spPr>
+          <a:xfrm>
+            <a:off x="4048404" y="2127500"/>
+            <a:ext cx="1083438" cy="338554"/>
+          </a:xfrm>
+          <a:prstGeom prst="rect">
+            <a:avLst/>
+          </a:prstGeom>
+          <a:noFill/>
+        </p:spPr>
+        <p:txBody>
+          <a:bodyPr wrap="none" rtlCol="0">
+            <a:spAutoFit/>
+          </a:bodyPr>
+          <a:lstStyle/>
+          <a:p>
+            <a:r>
+              <a:rPr lang="de-DE" sz="1600"/>
+              <a:t>Partition 2</a:t>
+            </a:r>
+          </a:p>
+        </p:txBody>
+      </p:sp>
+      <p:sp>
+        <p:nvSpPr>
+          <p:cNvPr id="15" name="Rechteck: abgerundete Ecken 14">
+            <a:extLst>
+              <a:ext uri="{FF2B5EF4-FFF2-40B4-BE49-F238E27FC236}">
+                <a16:creationId xmlns:a16="http://schemas.microsoft.com/office/drawing/2014/main" id="{8F1070FE-BAA0-4FDB-2682-24E83D4A96A5}"/>
+              </a:ext>
+            </a:extLst>
+          </p:cNvPr>
+          <p:cNvSpPr/>
+          <p:nvPr/>
+        </p:nvSpPr>
+        <p:spPr>
+          <a:xfrm>
+            <a:off x="4212585" y="2619975"/>
+            <a:ext cx="755076" cy="589130"/>
+          </a:xfrm>
+          <a:prstGeom prst="roundRect">
+            <a:avLst/>
+          </a:prstGeom>
+        </p:spPr>
+        <p:style>
+          <a:lnRef idx="1">
+            <a:schemeClr val="accent5"/>
+          </a:lnRef>
+          <a:fillRef idx="2">
+            <a:schemeClr val="accent5"/>
+          </a:fillRef>
+          <a:effectRef idx="1">
+            <a:schemeClr val="accent5"/>
+          </a:effectRef>
+          <a:fontRef idx="minor">
+            <a:schemeClr val="dk1"/>
+          </a:fontRef>
+        </p:style>
+        <p:txBody>
+          <a:bodyPr rtlCol="0" anchor="ctr"/>
+          <a:lstStyle/>
+          <a:p>
+            <a:pPr algn="ctr"/>
+            <a:r>
+              <a:rPr lang="de-DE"/>
+              <a:t>1</a:t>
+            </a:r>
+          </a:p>
+        </p:txBody>
+      </p:sp>
+      <p:sp>
+        <p:nvSpPr>
+          <p:cNvPr id="22" name="Rechteck: abgerundete Ecken 21">
+            <a:extLst>
+              <a:ext uri="{FF2B5EF4-FFF2-40B4-BE49-F238E27FC236}">
+                <a16:creationId xmlns:a16="http://schemas.microsoft.com/office/drawing/2014/main" id="{B21BFC6B-F7F2-3529-877D-5AF65CA3482F}"/>
+              </a:ext>
+            </a:extLst>
+          </p:cNvPr>
+          <p:cNvSpPr/>
+          <p:nvPr/>
+        </p:nvSpPr>
+        <p:spPr>
+          <a:xfrm>
+            <a:off x="2807432" y="3882175"/>
+            <a:ext cx="3622719" cy="866708"/>
+          </a:xfrm>
+          <a:prstGeom prst="roundRect">
+            <a:avLst/>
+          </a:prstGeom>
+          <a:solidFill>
+            <a:schemeClr val="bg1"/>
+          </a:solidFill>
+          <a:ln w="9525"/>
+        </p:spPr>
+        <p:style>
+          <a:lnRef idx="2">
+            <a:schemeClr val="accent1">
+              <a:shade val="15000"/>
+            </a:schemeClr>
+          </a:lnRef>
+          <a:fillRef idx="1">
+            <a:schemeClr val="accent1"/>
+          </a:fillRef>
+          <a:effectRef idx="0">
+            <a:schemeClr val="accent1"/>
+          </a:effectRef>
+          <a:fontRef idx="minor">
+            <a:schemeClr val="lt1"/>
+          </a:fontRef>
+        </p:style>
+        <p:txBody>
+          <a:bodyPr rtlCol="0" anchor="ctr"/>
+          <a:lstStyle/>
+          <a:p>
+            <a:pPr algn="ctr"/>
+            <a:endParaRPr lang="de-DE" sz="1000">
+              <a:solidFill>
+                <a:schemeClr val="tx1">
+                  <a:lumMod val="95000"/>
+                  <a:lumOff val="5000"/>
+                </a:schemeClr>
+              </a:solidFill>
+            </a:endParaRPr>
+          </a:p>
+        </p:txBody>
+      </p:sp>
+      <p:sp>
+        <p:nvSpPr>
+          <p:cNvPr id="23" name="Rechteck: abgerundete Ecken 22">
+            <a:extLst>
+              <a:ext uri="{FF2B5EF4-FFF2-40B4-BE49-F238E27FC236}">
+                <a16:creationId xmlns:a16="http://schemas.microsoft.com/office/drawing/2014/main" id="{BDF538F6-C88D-4374-CA99-CA1D69AB1C7A}"/>
+              </a:ext>
+            </a:extLst>
+          </p:cNvPr>
+          <p:cNvSpPr/>
+          <p:nvPr/>
+        </p:nvSpPr>
+        <p:spPr>
+          <a:xfrm>
+            <a:off x="3272046" y="3998594"/>
+            <a:ext cx="755076" cy="589130"/>
+          </a:xfrm>
+          <a:prstGeom prst="roundRect">
+            <a:avLst/>
+          </a:prstGeom>
+        </p:spPr>
+        <p:style>
+          <a:lnRef idx="1">
+            <a:schemeClr val="accent5"/>
+          </a:lnRef>
+          <a:fillRef idx="2">
+            <a:schemeClr val="accent5"/>
+          </a:fillRef>
+          <a:effectRef idx="1">
+            <a:schemeClr val="accent5"/>
+          </a:effectRef>
+          <a:fontRef idx="minor">
+            <a:schemeClr val="dk1"/>
+          </a:fontRef>
+        </p:style>
+        <p:txBody>
+          <a:bodyPr rtlCol="0" anchor="ctr"/>
+          <a:lstStyle/>
+          <a:p>
+            <a:pPr algn="ctr"/>
+            <a:r>
+              <a:rPr lang="de-DE"/>
+              <a:t>0</a:t>
+            </a:r>
+          </a:p>
+        </p:txBody>
+      </p:sp>
+      <p:sp>
+        <p:nvSpPr>
+          <p:cNvPr id="24" name="Textfeld 23">
+            <a:extLst>
+              <a:ext uri="{FF2B5EF4-FFF2-40B4-BE49-F238E27FC236}">
+                <a16:creationId xmlns:a16="http://schemas.microsoft.com/office/drawing/2014/main" id="{BB25B0F1-2207-7E38-6B78-EB9E88AB7006}"/>
+              </a:ext>
+            </a:extLst>
+          </p:cNvPr>
+          <p:cNvSpPr txBox="1"/>
+          <p:nvPr/>
+        </p:nvSpPr>
+        <p:spPr>
+          <a:xfrm>
+            <a:off x="4048404" y="3512843"/>
+            <a:ext cx="1083438" cy="338554"/>
+          </a:xfrm>
+          <a:prstGeom prst="rect">
+            <a:avLst/>
+          </a:prstGeom>
+          <a:noFill/>
+        </p:spPr>
+        <p:txBody>
+          <a:bodyPr wrap="none" rtlCol="0">
+            <a:spAutoFit/>
+          </a:bodyPr>
+          <a:lstStyle/>
+          <a:p>
+            <a:r>
+              <a:rPr lang="de-DE" sz="1600"/>
+              <a:t>Partition 3</a:t>
+            </a:r>
+          </a:p>
+        </p:txBody>
+      </p:sp>
+      <p:sp>
+        <p:nvSpPr>
+          <p:cNvPr id="26" name="Rechteck: abgerundete Ecken 25">
+            <a:extLst>
+              <a:ext uri="{FF2B5EF4-FFF2-40B4-BE49-F238E27FC236}">
+                <a16:creationId xmlns:a16="http://schemas.microsoft.com/office/drawing/2014/main" id="{C5E41060-A307-6119-4A0A-CE29CE3D5D7D}"/>
+              </a:ext>
+            </a:extLst>
+          </p:cNvPr>
+          <p:cNvSpPr/>
+          <p:nvPr/>
+        </p:nvSpPr>
+        <p:spPr>
+          <a:xfrm>
+            <a:off x="4212585" y="4005318"/>
+            <a:ext cx="755076" cy="589130"/>
+          </a:xfrm>
+          <a:prstGeom prst="roundRect">
+            <a:avLst/>
+          </a:prstGeom>
+        </p:spPr>
+        <p:style>
+          <a:lnRef idx="1">
+            <a:schemeClr val="accent5"/>
+          </a:lnRef>
+          <a:fillRef idx="2">
+            <a:schemeClr val="accent5"/>
+          </a:fillRef>
+          <a:effectRef idx="1">
+            <a:schemeClr val="accent5"/>
+          </a:effectRef>
+          <a:fontRef idx="minor">
+            <a:schemeClr val="dk1"/>
+          </a:fontRef>
+        </p:style>
+        <p:txBody>
+          <a:bodyPr rtlCol="0" anchor="ctr"/>
+          <a:lstStyle/>
+          <a:p>
+            <a:pPr algn="ctr"/>
+            <a:r>
+              <a:rPr lang="de-DE"/>
+              <a:t>1</a:t>
+            </a:r>
+          </a:p>
+        </p:txBody>
+      </p:sp>
+      <p:cxnSp>
+        <p:nvCxnSpPr>
+          <p:cNvPr id="28" name="Gerade Verbindung mit Pfeil 27">
+            <a:extLst>
+              <a:ext uri="{FF2B5EF4-FFF2-40B4-BE49-F238E27FC236}">
+                <a16:creationId xmlns:a16="http://schemas.microsoft.com/office/drawing/2014/main" id="{AACC479A-F0B4-6EC1-CD57-ABD89529132F}"/>
+              </a:ext>
+            </a:extLst>
+          </p:cNvPr>
+          <p:cNvCxnSpPr>
+            <a:cxnSpLocks/>
+            <a:stCxn id="47" idx="3"/>
+            <a:endCxn id="33" idx="1"/>
+          </p:cNvCxnSpPr>
+          <p:nvPr/>
+        </p:nvCxnSpPr>
+        <p:spPr>
+          <a:xfrm>
+            <a:off x="1502486" y="1633079"/>
+            <a:ext cx="1315020" cy="0"/>
+          </a:xfrm>
+          <a:prstGeom prst="straightConnector1">
+            <a:avLst/>
+          </a:prstGeom>
+          <a:ln>
+            <a:tailEnd type="triangle"/>
+          </a:ln>
+        </p:spPr>
+        <p:style>
+          <a:lnRef idx="2">
+            <a:schemeClr val="accent1"/>
+          </a:lnRef>
+          <a:fillRef idx="0">
+            <a:schemeClr val="accent1"/>
+          </a:fillRef>
+          <a:effectRef idx="1">
+            <a:schemeClr val="accent1"/>
+          </a:effectRef>
+          <a:fontRef idx="minor">
+            <a:schemeClr val="tx1"/>
+          </a:fontRef>
+        </p:style>
+      </p:cxnSp>
+      <p:sp>
+        <p:nvSpPr>
+          <p:cNvPr id="35" name="Rechteck: abgerundete Ecken 34">
+            <a:extLst>
+              <a:ext uri="{FF2B5EF4-FFF2-40B4-BE49-F238E27FC236}">
+                <a16:creationId xmlns:a16="http://schemas.microsoft.com/office/drawing/2014/main" id="{9950CE26-9602-77CD-83C8-249E050D0286}"/>
+              </a:ext>
+            </a:extLst>
+          </p:cNvPr>
+          <p:cNvSpPr/>
+          <p:nvPr/>
+        </p:nvSpPr>
+        <p:spPr>
+          <a:xfrm>
+            <a:off x="1807588" y="1426171"/>
+            <a:ext cx="511469" cy="345394"/>
+          </a:xfrm>
+          <a:prstGeom prst="roundRect">
+            <a:avLst/>
+          </a:prstGeom>
+        </p:spPr>
+        <p:style>
+          <a:lnRef idx="1">
+            <a:schemeClr val="accent5"/>
+          </a:lnRef>
+          <a:fillRef idx="2">
+            <a:schemeClr val="accent5"/>
+          </a:fillRef>
+          <a:effectRef idx="1">
+            <a:schemeClr val="accent5"/>
+          </a:effectRef>
+          <a:fontRef idx="minor">
+            <a:schemeClr val="dk1"/>
+          </a:fontRef>
+        </p:style>
+        <p:txBody>
+          <a:bodyPr rtlCol="0" anchor="ctr"/>
+          <a:lstStyle/>
+          <a:p>
+            <a:pPr algn="ctr"/>
             <a:endParaRPr lang="de-DE"/>
           </a:p>
         </p:txBody>
       </p:sp>
       <p:sp>
         <p:nvSpPr>
-          <p:cNvPr id="56" name="Rechteck: abgerundete Ecken 55">
-            <a:extLst>
-              <a:ext uri="{FF2B5EF4-FFF2-40B4-BE49-F238E27FC236}">
-                <a16:creationId xmlns:a16="http://schemas.microsoft.com/office/drawing/2014/main" id="{32666B4A-9E63-C20D-0062-5530CF1156A8}"/>
+          <p:cNvPr id="37" name="Rechteck: abgerundete Ecken 36">
+            <a:extLst>
+              <a:ext uri="{FF2B5EF4-FFF2-40B4-BE49-F238E27FC236}">
+                <a16:creationId xmlns:a16="http://schemas.microsoft.com/office/drawing/2014/main" id="{924AD6A0-C66A-530E-2857-77DE4456D08E}"/>
               </a:ext>
             </a:extLst>
           </p:cNvPr>
@@ -8433,11 +8799,594 @@
         </p:nvSpPr>
         <p:spPr>
           <a:xfrm>
-            <a:off x="5452335" y="3330339"/>
-            <a:ext cx="755076" cy="589130"/>
+            <a:off x="7835304" y="2700908"/>
+            <a:ext cx="1390483" cy="413815"/>
           </a:xfrm>
           <a:prstGeom prst="roundRect">
             <a:avLst/>
+          </a:prstGeom>
+        </p:spPr>
+        <p:style>
+          <a:lnRef idx="1">
+            <a:schemeClr val="accent6"/>
+          </a:lnRef>
+          <a:fillRef idx="2">
+            <a:schemeClr val="accent6"/>
+          </a:fillRef>
+          <a:effectRef idx="1">
+            <a:schemeClr val="accent6"/>
+          </a:effectRef>
+          <a:fontRef idx="minor">
+            <a:schemeClr val="dk1"/>
+          </a:fontRef>
+        </p:style>
+        <p:txBody>
+          <a:bodyPr rtlCol="0" anchor="ctr"/>
+          <a:lstStyle/>
+          <a:p>
+            <a:pPr algn="ctr"/>
+            <a:r>
+              <a:rPr lang="de-DE" b="1"/>
+              <a:t>Consumer</a:t>
+            </a:r>
+            <a:endParaRPr lang="de-DE" sz="1050"/>
+          </a:p>
+        </p:txBody>
+      </p:sp>
+      <p:sp>
+        <p:nvSpPr>
+          <p:cNvPr id="38" name="Rechteck: abgerundete Ecken 37">
+            <a:extLst>
+              <a:ext uri="{FF2B5EF4-FFF2-40B4-BE49-F238E27FC236}">
+                <a16:creationId xmlns:a16="http://schemas.microsoft.com/office/drawing/2014/main" id="{D1913D47-4E86-C1EA-DA79-43E7DD47A82E}"/>
+              </a:ext>
+            </a:extLst>
+          </p:cNvPr>
+          <p:cNvSpPr/>
+          <p:nvPr/>
+        </p:nvSpPr>
+        <p:spPr>
+          <a:xfrm>
+            <a:off x="7835304" y="4191819"/>
+            <a:ext cx="1390483" cy="413815"/>
+          </a:xfrm>
+          <a:prstGeom prst="roundRect">
+            <a:avLst/>
+          </a:prstGeom>
+        </p:spPr>
+        <p:style>
+          <a:lnRef idx="1">
+            <a:schemeClr val="accent6"/>
+          </a:lnRef>
+          <a:fillRef idx="2">
+            <a:schemeClr val="accent6"/>
+          </a:fillRef>
+          <a:effectRef idx="1">
+            <a:schemeClr val="accent6"/>
+          </a:effectRef>
+          <a:fontRef idx="minor">
+            <a:schemeClr val="dk1"/>
+          </a:fontRef>
+        </p:style>
+        <p:txBody>
+          <a:bodyPr rtlCol="0" anchor="ctr"/>
+          <a:lstStyle/>
+          <a:p>
+            <a:pPr algn="ctr"/>
+            <a:r>
+              <a:rPr lang="de-DE" b="1"/>
+              <a:t>Consumer</a:t>
+            </a:r>
+            <a:endParaRPr lang="de-DE" sz="1050"/>
+          </a:p>
+        </p:txBody>
+      </p:sp>
+      <p:sp>
+        <p:nvSpPr>
+          <p:cNvPr id="41" name="Rechteck: abgerundete Ecken 40">
+            <a:extLst>
+              <a:ext uri="{FF2B5EF4-FFF2-40B4-BE49-F238E27FC236}">
+                <a16:creationId xmlns:a16="http://schemas.microsoft.com/office/drawing/2014/main" id="{6F311AF4-84D9-CC51-B5EE-C65594E4036B}"/>
+              </a:ext>
+            </a:extLst>
+          </p:cNvPr>
+          <p:cNvSpPr/>
+          <p:nvPr/>
+        </p:nvSpPr>
+        <p:spPr>
+          <a:xfrm>
+            <a:off x="226631" y="2795290"/>
+            <a:ext cx="1284772" cy="413815"/>
+          </a:xfrm>
+          <a:prstGeom prst="roundRect">
+            <a:avLst/>
+          </a:prstGeom>
+        </p:spPr>
+        <p:style>
+          <a:lnRef idx="1">
+            <a:schemeClr val="accent4"/>
+          </a:lnRef>
+          <a:fillRef idx="2">
+            <a:schemeClr val="accent4"/>
+          </a:fillRef>
+          <a:effectRef idx="1">
+            <a:schemeClr val="accent4"/>
+          </a:effectRef>
+          <a:fontRef idx="minor">
+            <a:schemeClr val="dk1"/>
+          </a:fontRef>
+        </p:style>
+        <p:txBody>
+          <a:bodyPr rtlCol="0" anchor="ctr"/>
+          <a:lstStyle/>
+          <a:p>
+            <a:pPr algn="ctr"/>
+            <a:r>
+              <a:rPr lang="de-DE" b="1">
+                <a:solidFill>
+                  <a:schemeClr val="dk1"/>
+                </a:solidFill>
+              </a:rPr>
+              <a:t>Producer</a:t>
+            </a:r>
+            <a:endParaRPr lang="de-DE" sz="1050">
+              <a:solidFill>
+                <a:schemeClr val="dk1"/>
+              </a:solidFill>
+            </a:endParaRPr>
+          </a:p>
+        </p:txBody>
+      </p:sp>
+      <p:cxnSp>
+        <p:nvCxnSpPr>
+          <p:cNvPr id="42" name="Gerade Verbindung mit Pfeil 41">
+            <a:extLst>
+              <a:ext uri="{FF2B5EF4-FFF2-40B4-BE49-F238E27FC236}">
+                <a16:creationId xmlns:a16="http://schemas.microsoft.com/office/drawing/2014/main" id="{91A2A923-A4AF-8357-1169-E05508AAD910}"/>
+              </a:ext>
+            </a:extLst>
+          </p:cNvPr>
+          <p:cNvCxnSpPr>
+            <a:cxnSpLocks/>
+          </p:cNvCxnSpPr>
+          <p:nvPr/>
+        </p:nvCxnSpPr>
+        <p:spPr>
+          <a:xfrm>
+            <a:off x="1511403" y="3002419"/>
+            <a:ext cx="1315020" cy="0"/>
+          </a:xfrm>
+          <a:prstGeom prst="straightConnector1">
+            <a:avLst/>
+          </a:prstGeom>
+          <a:ln>
+            <a:tailEnd type="triangle"/>
+          </a:ln>
+        </p:spPr>
+        <p:style>
+          <a:lnRef idx="2">
+            <a:schemeClr val="accent1"/>
+          </a:lnRef>
+          <a:fillRef idx="0">
+            <a:schemeClr val="accent1"/>
+          </a:fillRef>
+          <a:effectRef idx="1">
+            <a:schemeClr val="accent1"/>
+          </a:effectRef>
+          <a:fontRef idx="minor">
+            <a:schemeClr val="tx1"/>
+          </a:fontRef>
+        </p:style>
+      </p:cxnSp>
+      <p:cxnSp>
+        <p:nvCxnSpPr>
+          <p:cNvPr id="43" name="Gerade Verbindung mit Pfeil 42">
+            <a:extLst>
+              <a:ext uri="{FF2B5EF4-FFF2-40B4-BE49-F238E27FC236}">
+                <a16:creationId xmlns:a16="http://schemas.microsoft.com/office/drawing/2014/main" id="{237A4B08-EDA7-BE3D-65AB-2ECB527E4D55}"/>
+              </a:ext>
+            </a:extLst>
+          </p:cNvPr>
+          <p:cNvCxnSpPr>
+            <a:cxnSpLocks/>
+            <a:stCxn id="41" idx="3"/>
+            <a:endCxn id="22" idx="1"/>
+          </p:cNvCxnSpPr>
+          <p:nvPr/>
+        </p:nvCxnSpPr>
+        <p:spPr>
+          <a:xfrm>
+            <a:off x="1511403" y="3002198"/>
+            <a:ext cx="1296029" cy="1313331"/>
+          </a:xfrm>
+          <a:prstGeom prst="straightConnector1">
+            <a:avLst/>
+          </a:prstGeom>
+          <a:ln>
+            <a:tailEnd type="triangle"/>
+          </a:ln>
+        </p:spPr>
+        <p:style>
+          <a:lnRef idx="2">
+            <a:schemeClr val="accent1"/>
+          </a:lnRef>
+          <a:fillRef idx="0">
+            <a:schemeClr val="accent1"/>
+          </a:fillRef>
+          <a:effectRef idx="1">
+            <a:schemeClr val="accent1"/>
+          </a:effectRef>
+          <a:fontRef idx="minor">
+            <a:schemeClr val="tx1"/>
+          </a:fontRef>
+        </p:style>
+      </p:cxnSp>
+      <p:sp>
+        <p:nvSpPr>
+          <p:cNvPr id="46" name="Rechteck: abgerundete Ecken 45">
+            <a:extLst>
+              <a:ext uri="{FF2B5EF4-FFF2-40B4-BE49-F238E27FC236}">
+                <a16:creationId xmlns:a16="http://schemas.microsoft.com/office/drawing/2014/main" id="{B5A02B36-4EBF-9B20-17AD-24EB4D9B2479}"/>
+              </a:ext>
+            </a:extLst>
+          </p:cNvPr>
+          <p:cNvSpPr/>
+          <p:nvPr/>
+        </p:nvSpPr>
+        <p:spPr>
+          <a:xfrm>
+            <a:off x="1834978" y="2757489"/>
+            <a:ext cx="511469" cy="345394"/>
+          </a:xfrm>
+          <a:prstGeom prst="roundRect">
+            <a:avLst/>
+          </a:prstGeom>
+        </p:spPr>
+        <p:style>
+          <a:lnRef idx="1">
+            <a:schemeClr val="accent5"/>
+          </a:lnRef>
+          <a:fillRef idx="2">
+            <a:schemeClr val="accent5"/>
+          </a:fillRef>
+          <a:effectRef idx="1">
+            <a:schemeClr val="accent5"/>
+          </a:effectRef>
+          <a:fontRef idx="minor">
+            <a:schemeClr val="dk1"/>
+          </a:fontRef>
+        </p:style>
+        <p:txBody>
+          <a:bodyPr rtlCol="0" anchor="ctr"/>
+          <a:lstStyle/>
+          <a:p>
+            <a:pPr algn="ctr"/>
+            <a:endParaRPr lang="de-DE"/>
+          </a:p>
+        </p:txBody>
+      </p:sp>
+      <p:sp>
+        <p:nvSpPr>
+          <p:cNvPr id="51" name="Rechteck: abgerundete Ecken 50">
+            <a:extLst>
+              <a:ext uri="{FF2B5EF4-FFF2-40B4-BE49-F238E27FC236}">
+                <a16:creationId xmlns:a16="http://schemas.microsoft.com/office/drawing/2014/main" id="{1FBEE5AB-F89B-E52E-0582-B0C41EAE5E48}"/>
+              </a:ext>
+            </a:extLst>
+          </p:cNvPr>
+          <p:cNvSpPr/>
+          <p:nvPr/>
+        </p:nvSpPr>
+        <p:spPr>
+          <a:xfrm>
+            <a:off x="1807588" y="3436165"/>
+            <a:ext cx="511469" cy="345394"/>
+          </a:xfrm>
+          <a:prstGeom prst="roundRect">
+            <a:avLst/>
+          </a:prstGeom>
+        </p:spPr>
+        <p:style>
+          <a:lnRef idx="1">
+            <a:schemeClr val="accent5"/>
+          </a:lnRef>
+          <a:fillRef idx="2">
+            <a:schemeClr val="accent5"/>
+          </a:fillRef>
+          <a:effectRef idx="1">
+            <a:schemeClr val="accent5"/>
+          </a:effectRef>
+          <a:fontRef idx="minor">
+            <a:schemeClr val="dk1"/>
+          </a:fontRef>
+        </p:style>
+        <p:txBody>
+          <a:bodyPr rtlCol="0" anchor="ctr"/>
+          <a:lstStyle/>
+          <a:p>
+            <a:pPr algn="ctr"/>
+            <a:endParaRPr lang="de-DE"/>
+          </a:p>
+        </p:txBody>
+      </p:sp>
+      <p:cxnSp>
+        <p:nvCxnSpPr>
+          <p:cNvPr id="62" name="Gerade Verbindung mit Pfeil 61">
+            <a:extLst>
+              <a:ext uri="{FF2B5EF4-FFF2-40B4-BE49-F238E27FC236}">
+                <a16:creationId xmlns:a16="http://schemas.microsoft.com/office/drawing/2014/main" id="{5E032A44-3B90-01BF-3436-47246BC8F85D}"/>
+              </a:ext>
+            </a:extLst>
+          </p:cNvPr>
+          <p:cNvCxnSpPr>
+            <a:cxnSpLocks/>
+            <a:endCxn id="48" idx="1"/>
+          </p:cNvCxnSpPr>
+          <p:nvPr/>
+        </p:nvCxnSpPr>
+        <p:spPr>
+          <a:xfrm>
+            <a:off x="6430151" y="1529775"/>
+            <a:ext cx="1444994" cy="1"/>
+          </a:xfrm>
+          <a:prstGeom prst="straightConnector1">
+            <a:avLst/>
+          </a:prstGeom>
+          <a:ln>
+            <a:tailEnd type="triangle"/>
+          </a:ln>
+        </p:spPr>
+        <p:style>
+          <a:lnRef idx="2">
+            <a:schemeClr val="accent1"/>
+          </a:lnRef>
+          <a:fillRef idx="0">
+            <a:schemeClr val="accent1"/>
+          </a:fillRef>
+          <a:effectRef idx="1">
+            <a:schemeClr val="accent1"/>
+          </a:effectRef>
+          <a:fontRef idx="minor">
+            <a:schemeClr val="tx1"/>
+          </a:fontRef>
+        </p:style>
+      </p:cxnSp>
+      <p:cxnSp>
+        <p:nvCxnSpPr>
+          <p:cNvPr id="1025" name="Gerade Verbindung mit Pfeil 1024">
+            <a:extLst>
+              <a:ext uri="{FF2B5EF4-FFF2-40B4-BE49-F238E27FC236}">
+                <a16:creationId xmlns:a16="http://schemas.microsoft.com/office/drawing/2014/main" id="{66EE35F4-6697-4E7E-FA34-9E11198E8712}"/>
+              </a:ext>
+            </a:extLst>
+          </p:cNvPr>
+          <p:cNvCxnSpPr>
+            <a:cxnSpLocks/>
+            <a:stCxn id="12" idx="3"/>
+          </p:cNvCxnSpPr>
+          <p:nvPr/>
+        </p:nvCxnSpPr>
+        <p:spPr>
+          <a:xfrm flipV="1">
+            <a:off x="6430151" y="2914541"/>
+            <a:ext cx="1405153" cy="15645"/>
+          </a:xfrm>
+          <a:prstGeom prst="straightConnector1">
+            <a:avLst/>
+          </a:prstGeom>
+          <a:ln>
+            <a:tailEnd type="triangle"/>
+          </a:ln>
+        </p:spPr>
+        <p:style>
+          <a:lnRef idx="2">
+            <a:schemeClr val="accent1"/>
+          </a:lnRef>
+          <a:fillRef idx="0">
+            <a:schemeClr val="accent1"/>
+          </a:fillRef>
+          <a:effectRef idx="1">
+            <a:schemeClr val="accent1"/>
+          </a:effectRef>
+          <a:fontRef idx="minor">
+            <a:schemeClr val="tx1"/>
+          </a:fontRef>
+        </p:style>
+      </p:cxnSp>
+      <p:cxnSp>
+        <p:nvCxnSpPr>
+          <p:cNvPr id="1027" name="Gerade Verbindung mit Pfeil 1026">
+            <a:extLst>
+              <a:ext uri="{FF2B5EF4-FFF2-40B4-BE49-F238E27FC236}">
+                <a16:creationId xmlns:a16="http://schemas.microsoft.com/office/drawing/2014/main" id="{4D2B6F3D-4230-970F-812B-2491DD8E6DBC}"/>
+              </a:ext>
+            </a:extLst>
+          </p:cNvPr>
+          <p:cNvCxnSpPr>
+            <a:cxnSpLocks/>
+          </p:cNvCxnSpPr>
+          <p:nvPr/>
+        </p:nvCxnSpPr>
+        <p:spPr>
+          <a:xfrm>
+            <a:off x="6430151" y="4440635"/>
+            <a:ext cx="1444994" cy="1"/>
+          </a:xfrm>
+          <a:prstGeom prst="straightConnector1">
+            <a:avLst/>
+          </a:prstGeom>
+          <a:ln>
+            <a:tailEnd type="triangle"/>
+          </a:ln>
+        </p:spPr>
+        <p:style>
+          <a:lnRef idx="2">
+            <a:schemeClr val="accent1"/>
+          </a:lnRef>
+          <a:fillRef idx="0">
+            <a:schemeClr val="accent1"/>
+          </a:fillRef>
+          <a:effectRef idx="1">
+            <a:schemeClr val="accent1"/>
+          </a:effectRef>
+          <a:fontRef idx="minor">
+            <a:schemeClr val="tx1"/>
+          </a:fontRef>
+        </p:style>
+      </p:cxnSp>
+      <p:sp>
+        <p:nvSpPr>
+          <p:cNvPr id="1033" name="Rechteck: abgerundete Ecken 1032">
+            <a:extLst>
+              <a:ext uri="{FF2B5EF4-FFF2-40B4-BE49-F238E27FC236}">
+                <a16:creationId xmlns:a16="http://schemas.microsoft.com/office/drawing/2014/main" id="{67763C30-664A-DA70-0E4F-76EDB255F470}"/>
+              </a:ext>
+            </a:extLst>
+          </p:cNvPr>
+          <p:cNvSpPr/>
+          <p:nvPr/>
+        </p:nvSpPr>
+        <p:spPr>
+          <a:xfrm>
+            <a:off x="6923582" y="1322868"/>
+            <a:ext cx="511469" cy="345394"/>
+          </a:xfrm>
+          <a:prstGeom prst="roundRect">
+            <a:avLst/>
+          </a:prstGeom>
+        </p:spPr>
+        <p:style>
+          <a:lnRef idx="1">
+            <a:schemeClr val="accent5"/>
+          </a:lnRef>
+          <a:fillRef idx="2">
+            <a:schemeClr val="accent5"/>
+          </a:fillRef>
+          <a:effectRef idx="1">
+            <a:schemeClr val="accent5"/>
+          </a:effectRef>
+          <a:fontRef idx="minor">
+            <a:schemeClr val="dk1"/>
+          </a:fontRef>
+        </p:style>
+        <p:txBody>
+          <a:bodyPr rtlCol="0" anchor="ctr"/>
+          <a:lstStyle/>
+          <a:p>
+            <a:pPr algn="ctr"/>
+            <a:endParaRPr lang="de-DE"/>
+          </a:p>
+        </p:txBody>
+      </p:sp>
+      <p:sp>
+        <p:nvSpPr>
+          <p:cNvPr id="1034" name="Rechteck: abgerundete Ecken 1033">
+            <a:extLst>
+              <a:ext uri="{FF2B5EF4-FFF2-40B4-BE49-F238E27FC236}">
+                <a16:creationId xmlns:a16="http://schemas.microsoft.com/office/drawing/2014/main" id="{50573265-659B-D19D-125F-9F18517CCB3B}"/>
+              </a:ext>
+            </a:extLst>
+          </p:cNvPr>
+          <p:cNvSpPr/>
+          <p:nvPr/>
+        </p:nvSpPr>
+        <p:spPr>
+          <a:xfrm>
+            <a:off x="6941674" y="2750238"/>
+            <a:ext cx="511469" cy="345394"/>
+          </a:xfrm>
+          <a:prstGeom prst="roundRect">
+            <a:avLst/>
+          </a:prstGeom>
+        </p:spPr>
+        <p:style>
+          <a:lnRef idx="1">
+            <a:schemeClr val="accent5"/>
+          </a:lnRef>
+          <a:fillRef idx="2">
+            <a:schemeClr val="accent5"/>
+          </a:fillRef>
+          <a:effectRef idx="1">
+            <a:schemeClr val="accent5"/>
+          </a:effectRef>
+          <a:fontRef idx="minor">
+            <a:schemeClr val="dk1"/>
+          </a:fontRef>
+        </p:style>
+        <p:txBody>
+          <a:bodyPr rtlCol="0" anchor="ctr"/>
+          <a:lstStyle/>
+          <a:p>
+            <a:pPr algn="ctr"/>
+            <a:endParaRPr lang="de-DE"/>
+          </a:p>
+        </p:txBody>
+      </p:sp>
+      <p:sp>
+        <p:nvSpPr>
+          <p:cNvPr id="1035" name="Rechteck: abgerundete Ecken 1034">
+            <a:extLst>
+              <a:ext uri="{FF2B5EF4-FFF2-40B4-BE49-F238E27FC236}">
+                <a16:creationId xmlns:a16="http://schemas.microsoft.com/office/drawing/2014/main" id="{1F2765F2-7768-78EB-6D35-5A52DEF38521}"/>
+              </a:ext>
+            </a:extLst>
+          </p:cNvPr>
+          <p:cNvSpPr/>
+          <p:nvPr/>
+        </p:nvSpPr>
+        <p:spPr>
+          <a:xfrm>
+            <a:off x="6888406" y="4274661"/>
+            <a:ext cx="511469" cy="345394"/>
+          </a:xfrm>
+          <a:prstGeom prst="roundRect">
+            <a:avLst/>
+          </a:prstGeom>
+        </p:spPr>
+        <p:style>
+          <a:lnRef idx="1">
+            <a:schemeClr val="accent5"/>
+          </a:lnRef>
+          <a:fillRef idx="2">
+            <a:schemeClr val="accent5"/>
+          </a:fillRef>
+          <a:effectRef idx="1">
+            <a:schemeClr val="accent5"/>
+          </a:effectRef>
+          <a:fontRef idx="minor">
+            <a:schemeClr val="dk1"/>
+          </a:fontRef>
+        </p:style>
+        <p:txBody>
+          <a:bodyPr rtlCol="0" anchor="ctr"/>
+          <a:lstStyle/>
+          <a:p>
+            <a:pPr algn="ctr"/>
+            <a:endParaRPr lang="de-DE"/>
+          </a:p>
+        </p:txBody>
+      </p:sp>
+      <p:sp>
+        <p:nvSpPr>
+          <p:cNvPr id="1036" name="Rechteck: abgerundete Ecken 1035">
+            <a:extLst>
+              <a:ext uri="{FF2B5EF4-FFF2-40B4-BE49-F238E27FC236}">
+                <a16:creationId xmlns:a16="http://schemas.microsoft.com/office/drawing/2014/main" id="{6DF44DAB-5151-D8E2-157F-55106DC32431}"/>
+              </a:ext>
+            </a:extLst>
+          </p:cNvPr>
+          <p:cNvSpPr/>
+          <p:nvPr/>
+        </p:nvSpPr>
+        <p:spPr>
+          <a:xfrm>
+            <a:off x="2498514" y="5224920"/>
+            <a:ext cx="4100277" cy="1829259"/>
+          </a:xfrm>
+          <a:prstGeom prst="roundRect">
+            <a:avLst>
+              <a:gd name="adj" fmla="val 9662"/>
+            </a:avLst>
           </a:prstGeom>
           <a:gradFill>
             <a:gsLst>
@@ -8477,137 +9426,20 @@
           <a:lstStyle/>
           <a:p>
             <a:pPr algn="ctr"/>
-            <a:endParaRPr lang="de-DE"/>
-          </a:p>
-        </p:txBody>
-      </p:sp>
-      <p:sp>
-        <p:nvSpPr>
-          <p:cNvPr id="57" name="Rechteck: abgerundete Ecken 56">
-            <a:extLst>
-              <a:ext uri="{FF2B5EF4-FFF2-40B4-BE49-F238E27FC236}">
-                <a16:creationId xmlns:a16="http://schemas.microsoft.com/office/drawing/2014/main" id="{11EDF3AE-C7F5-49C3-74C1-88D6C885F4C5}"/>
-              </a:ext>
-            </a:extLst>
-          </p:cNvPr>
-          <p:cNvSpPr/>
-          <p:nvPr/>
-        </p:nvSpPr>
-        <p:spPr>
-          <a:xfrm>
-            <a:off x="6310880" y="3313494"/>
-            <a:ext cx="755076" cy="589130"/>
-          </a:xfrm>
-          <a:prstGeom prst="roundRect">
-            <a:avLst/>
-          </a:prstGeom>
-          <a:gradFill>
-            <a:gsLst>
-              <a:gs pos="0">
-                <a:srgbClr val="FFFFCD"/>
-              </a:gs>
-              <a:gs pos="50000">
-                <a:srgbClr val="FFFFA7"/>
-              </a:gs>
-              <a:gs pos="100000">
-                <a:srgbClr val="FFFF99"/>
-              </a:gs>
-            </a:gsLst>
-          </a:gradFill>
-          <a:ln>
-            <a:solidFill>
-              <a:srgbClr val="C0BC00"/>
-            </a:solidFill>
-          </a:ln>
-        </p:spPr>
-        <p:style>
-          <a:lnRef idx="1">
-            <a:schemeClr val="accent2"/>
-          </a:lnRef>
-          <a:fillRef idx="2">
-            <a:schemeClr val="accent2"/>
-          </a:fillRef>
-          <a:effectRef idx="1">
-            <a:schemeClr val="accent2"/>
-          </a:effectRef>
-          <a:fontRef idx="minor">
-            <a:schemeClr val="dk1"/>
-          </a:fontRef>
-        </p:style>
-        <p:txBody>
-          <a:bodyPr rtlCol="0" anchor="ctr"/>
-          <a:lstStyle/>
-          <a:p>
-            <a:pPr algn="ctr"/>
-            <a:endParaRPr lang="de-DE"/>
-          </a:p>
-        </p:txBody>
-      </p:sp>
-      <p:sp>
-        <p:nvSpPr>
-          <p:cNvPr id="58" name="Rechteck: abgerundete Ecken 57">
-            <a:extLst>
-              <a:ext uri="{FF2B5EF4-FFF2-40B4-BE49-F238E27FC236}">
-                <a16:creationId xmlns:a16="http://schemas.microsoft.com/office/drawing/2014/main" id="{092A69D5-B4C8-336E-7533-4F49FFFC09F9}"/>
-              </a:ext>
-            </a:extLst>
-          </p:cNvPr>
-          <p:cNvSpPr/>
-          <p:nvPr/>
-        </p:nvSpPr>
-        <p:spPr>
-          <a:xfrm>
-            <a:off x="4704094" y="1382955"/>
-            <a:ext cx="255976" cy="176304"/>
-          </a:xfrm>
-          <a:prstGeom prst="roundRect">
-            <a:avLst/>
-          </a:prstGeom>
-          <a:solidFill>
-            <a:schemeClr val="bg1">
-              <a:lumMod val="95000"/>
-            </a:schemeClr>
-          </a:solidFill>
-          <a:ln w="6350">
-            <a:solidFill>
-              <a:schemeClr val="tx1">
-                <a:lumMod val="65000"/>
-                <a:lumOff val="35000"/>
-              </a:schemeClr>
-            </a:solidFill>
-          </a:ln>
-        </p:spPr>
-        <p:style>
-          <a:lnRef idx="2">
-            <a:schemeClr val="accent2">
-              <a:shade val="15000"/>
-            </a:schemeClr>
-          </a:lnRef>
-          <a:fillRef idx="1">
-            <a:schemeClr val="accent2"/>
-          </a:fillRef>
-          <a:effectRef idx="0">
-            <a:schemeClr val="accent2"/>
-          </a:effectRef>
-          <a:fontRef idx="minor">
-            <a:schemeClr val="lt1"/>
-          </a:fontRef>
-        </p:style>
-        <p:txBody>
-          <a:bodyPr rtlCol="0" anchor="ctr"/>
-          <a:lstStyle/>
-          <a:p>
-            <a:pPr algn="ctr"/>
-            <a:endParaRPr lang="de-DE" sz="1000"/>
-          </a:p>
-        </p:txBody>
-      </p:sp>
-      <p:sp>
-        <p:nvSpPr>
-          <p:cNvPr id="29" name="Textfeld 28">
-            <a:extLst>
-              <a:ext uri="{FF2B5EF4-FFF2-40B4-BE49-F238E27FC236}">
-                <a16:creationId xmlns:a16="http://schemas.microsoft.com/office/drawing/2014/main" id="{4C93006F-118D-2027-B195-4D511998BFCE}"/>
+            <a:endParaRPr lang="de-DE">
+              <a:solidFill>
+                <a:schemeClr val="dk1"/>
+              </a:solidFill>
+            </a:endParaRPr>
+          </a:p>
+        </p:txBody>
+      </p:sp>
+      <p:sp>
+        <p:nvSpPr>
+          <p:cNvPr id="1037" name="Textfeld 1036">
+            <a:extLst>
+              <a:ext uri="{FF2B5EF4-FFF2-40B4-BE49-F238E27FC236}">
+                <a16:creationId xmlns:a16="http://schemas.microsoft.com/office/drawing/2014/main" id="{B3816152-32A1-1969-A27E-A1BE48A1112D}"/>
               </a:ext>
             </a:extLst>
           </p:cNvPr>
@@ -8616,8 +9448,8 @@
         </p:nvSpPr>
         <p:spPr>
           <a:xfrm>
-            <a:off x="6325289" y="3625625"/>
-            <a:ext cx="743730" cy="276999"/>
+            <a:off x="2664148" y="5247291"/>
+            <a:ext cx="929229" cy="369332"/>
           </a:xfrm>
           <a:prstGeom prst="rect">
             <a:avLst/>
@@ -8631,18 +9463,18 @@
           <a:lstStyle/>
           <a:p>
             <a:r>
-              <a:rPr lang="de-DE" sz="1200"/>
-              <a:t>Partition</a:t>
-            </a:r>
-          </a:p>
-        </p:txBody>
-      </p:sp>
-      <p:sp>
-        <p:nvSpPr>
-          <p:cNvPr id="59" name="Rechteck: abgerundete Ecken 58">
-            <a:extLst>
-              <a:ext uri="{FF2B5EF4-FFF2-40B4-BE49-F238E27FC236}">
-                <a16:creationId xmlns:a16="http://schemas.microsoft.com/office/drawing/2014/main" id="{BEBE8B59-B5C5-EF7F-A0B9-81E8076D1DA8}"/>
+              <a:rPr lang="de-DE" b="1"/>
+              <a:t>Topic B</a:t>
+            </a:r>
+          </a:p>
+        </p:txBody>
+      </p:sp>
+      <p:sp>
+        <p:nvSpPr>
+          <p:cNvPr id="1038" name="Rechteck: abgerundete Ecken 1037">
+            <a:extLst>
+              <a:ext uri="{FF2B5EF4-FFF2-40B4-BE49-F238E27FC236}">
+                <a16:creationId xmlns:a16="http://schemas.microsoft.com/office/drawing/2014/main" id="{6A9F377E-5A2A-BAB9-EAB2-1DE791E492F4}"/>
               </a:ext>
             </a:extLst>
           </p:cNvPr>
@@ -8651,40 +9483,82 @@
         </p:nvSpPr>
         <p:spPr>
           <a:xfrm>
-            <a:off x="5002664" y="1382955"/>
-            <a:ext cx="255976" cy="176304"/>
+            <a:off x="2664148" y="6018005"/>
+            <a:ext cx="3622719" cy="866708"/>
           </a:xfrm>
           <a:prstGeom prst="roundRect">
             <a:avLst/>
           </a:prstGeom>
           <a:solidFill>
-            <a:schemeClr val="bg1">
-              <a:lumMod val="95000"/>
-            </a:schemeClr>
+            <a:schemeClr val="bg1"/>
           </a:solidFill>
-          <a:ln w="6350">
-            <a:solidFill>
-              <a:schemeClr val="tx1">
-                <a:lumMod val="65000"/>
-                <a:lumOff val="35000"/>
-              </a:schemeClr>
-            </a:solidFill>
-          </a:ln>
+          <a:ln w="9525"/>
         </p:spPr>
         <p:style>
           <a:lnRef idx="2">
-            <a:schemeClr val="accent2">
+            <a:schemeClr val="accent1">
               <a:shade val="15000"/>
             </a:schemeClr>
           </a:lnRef>
           <a:fillRef idx="1">
+            <a:schemeClr val="accent1"/>
+          </a:fillRef>
+          <a:effectRef idx="0">
+            <a:schemeClr val="accent1"/>
+          </a:effectRef>
+          <a:fontRef idx="minor">
+            <a:schemeClr val="lt1"/>
+          </a:fontRef>
+        </p:style>
+        <p:txBody>
+          <a:bodyPr rtlCol="0" anchor="ctr"/>
+          <a:lstStyle/>
+          <a:p>
+            <a:pPr algn="ctr"/>
+            <a:endParaRPr lang="de-DE" sz="1000">
+              <a:solidFill>
+                <a:schemeClr val="tx1">
+                  <a:lumMod val="95000"/>
+                  <a:lumOff val="5000"/>
+                </a:schemeClr>
+              </a:solidFill>
+            </a:endParaRPr>
+          </a:p>
+        </p:txBody>
+      </p:sp>
+      <p:sp>
+        <p:nvSpPr>
+          <p:cNvPr id="1039" name="Rechteck: abgerundete Ecken 1038">
+            <a:extLst>
+              <a:ext uri="{FF2B5EF4-FFF2-40B4-BE49-F238E27FC236}">
+                <a16:creationId xmlns:a16="http://schemas.microsoft.com/office/drawing/2014/main" id="{737FEFD0-9EA5-B6B7-2161-A2136D2D5337}"/>
+              </a:ext>
+            </a:extLst>
+          </p:cNvPr>
+          <p:cNvSpPr/>
+          <p:nvPr/>
+        </p:nvSpPr>
+        <p:spPr>
+          <a:xfrm>
+            <a:off x="3128762" y="6134424"/>
+            <a:ext cx="755076" cy="589130"/>
+          </a:xfrm>
+          <a:prstGeom prst="roundRect">
+            <a:avLst/>
+          </a:prstGeom>
+        </p:spPr>
+        <p:style>
+          <a:lnRef idx="1">
             <a:schemeClr val="accent2"/>
-          </a:fillRef>
-          <a:effectRef idx="0">
+          </a:lnRef>
+          <a:fillRef idx="2">
             <a:schemeClr val="accent2"/>
-          </a:effectRef>
-          <a:fontRef idx="minor">
-            <a:schemeClr val="lt1"/>
+          </a:fillRef>
+          <a:effectRef idx="1">
+            <a:schemeClr val="accent2"/>
+          </a:effectRef>
+          <a:fontRef idx="minor">
+            <a:schemeClr val="dk1"/>
           </a:fontRef>
         </p:style>
         <p:txBody>
@@ -8692,209 +9566,515 @@
           <a:lstStyle/>
           <a:p>
             <a:pPr algn="ctr"/>
-            <a:endParaRPr lang="de-DE" sz="1000"/>
-          </a:p>
-        </p:txBody>
-      </p:sp>
-      <p:sp>
-        <p:nvSpPr>
-          <p:cNvPr id="60" name="Rechteck: abgerundete Ecken 59">
-            <a:extLst>
-              <a:ext uri="{FF2B5EF4-FFF2-40B4-BE49-F238E27FC236}">
-                <a16:creationId xmlns:a16="http://schemas.microsoft.com/office/drawing/2014/main" id="{9D408EE9-F32A-0B64-D771-BFEF7B653605}"/>
-              </a:ext>
-            </a:extLst>
-          </p:cNvPr>
-          <p:cNvSpPr/>
-          <p:nvPr/>
-        </p:nvSpPr>
-        <p:spPr>
-          <a:xfrm>
-            <a:off x="5529017" y="1382955"/>
-            <a:ext cx="255976" cy="176304"/>
-          </a:xfrm>
-          <a:prstGeom prst="roundRect">
-            <a:avLst/>
-          </a:prstGeom>
-          <a:solidFill>
-            <a:schemeClr val="bg1">
-              <a:lumMod val="95000"/>
-            </a:schemeClr>
-          </a:solidFill>
-          <a:ln w="6350">
-            <a:solidFill>
-              <a:schemeClr val="tx1">
-                <a:lumMod val="65000"/>
-                <a:lumOff val="35000"/>
-              </a:schemeClr>
-            </a:solidFill>
-          </a:ln>
-        </p:spPr>
-        <p:style>
-          <a:lnRef idx="2">
-            <a:schemeClr val="accent2">
-              <a:shade val="15000"/>
-            </a:schemeClr>
-          </a:lnRef>
-          <a:fillRef idx="1">
-            <a:schemeClr val="accent2"/>
-          </a:fillRef>
-          <a:effectRef idx="0">
-            <a:schemeClr val="accent2"/>
-          </a:effectRef>
-          <a:fontRef idx="minor">
-            <a:schemeClr val="lt1"/>
-          </a:fontRef>
-        </p:style>
-        <p:txBody>
-          <a:bodyPr rtlCol="0" anchor="ctr"/>
-          <a:lstStyle/>
-          <a:p>
-            <a:pPr algn="ctr"/>
-            <a:endParaRPr lang="de-DE" sz="1000"/>
-          </a:p>
-        </p:txBody>
-      </p:sp>
-      <p:sp>
-        <p:nvSpPr>
-          <p:cNvPr id="61" name="Rechteck: abgerundete Ecken 60">
-            <a:extLst>
-              <a:ext uri="{FF2B5EF4-FFF2-40B4-BE49-F238E27FC236}">
-                <a16:creationId xmlns:a16="http://schemas.microsoft.com/office/drawing/2014/main" id="{D5B09D46-9C52-5C9A-D0F4-DAE3217E20EE}"/>
-              </a:ext>
-            </a:extLst>
-          </p:cNvPr>
-          <p:cNvSpPr/>
-          <p:nvPr/>
-        </p:nvSpPr>
-        <p:spPr>
-          <a:xfrm>
-            <a:off x="6352465" y="1382955"/>
-            <a:ext cx="255976" cy="176304"/>
-          </a:xfrm>
-          <a:prstGeom prst="roundRect">
-            <a:avLst/>
-          </a:prstGeom>
-          <a:solidFill>
-            <a:schemeClr val="bg1">
-              <a:lumMod val="95000"/>
-            </a:schemeClr>
-          </a:solidFill>
-          <a:ln w="6350">
-            <a:solidFill>
-              <a:schemeClr val="tx1">
-                <a:lumMod val="65000"/>
-                <a:lumOff val="35000"/>
-              </a:schemeClr>
-            </a:solidFill>
-          </a:ln>
-        </p:spPr>
-        <p:style>
-          <a:lnRef idx="2">
-            <a:schemeClr val="accent2">
-              <a:shade val="15000"/>
-            </a:schemeClr>
-          </a:lnRef>
-          <a:fillRef idx="1">
-            <a:schemeClr val="accent2"/>
-          </a:fillRef>
-          <a:effectRef idx="0">
-            <a:schemeClr val="accent2"/>
-          </a:effectRef>
-          <a:fontRef idx="minor">
-            <a:schemeClr val="lt1"/>
-          </a:fontRef>
-        </p:style>
-        <p:txBody>
-          <a:bodyPr rtlCol="0" anchor="ctr"/>
-          <a:lstStyle/>
-          <a:p>
-            <a:pPr algn="ctr"/>
-            <a:endParaRPr lang="de-DE" sz="1000"/>
-          </a:p>
-        </p:txBody>
-      </p:sp>
-      <p:pic>
-        <p:nvPicPr>
-          <p:cNvPr id="1026" name="Picture 2" descr="Apache Kafka">
-            <a:extLst>
-              <a:ext uri="{FF2B5EF4-FFF2-40B4-BE49-F238E27FC236}">
-                <a16:creationId xmlns:a16="http://schemas.microsoft.com/office/drawing/2014/main" id="{19DAC144-DFD1-B5AE-BD38-A9A3464688D7}"/>
-              </a:ext>
-            </a:extLst>
-          </p:cNvPr>
-          <p:cNvPicPr>
-            <a:picLocks noChangeAspect="1" noChangeArrowheads="1"/>
-          </p:cNvPicPr>
-          <p:nvPr/>
-        </p:nvPicPr>
-        <p:blipFill>
-          <a:blip r:embed="rId2">
-            <a:extLst>
-              <a:ext uri="{28A0092B-C50C-407E-A947-70E740481C1C}">
-                <a14:useLocalDpi xmlns:a14="http://schemas.microsoft.com/office/drawing/2010/main" val="0"/>
-              </a:ext>
-            </a:extLst>
-          </a:blip>
-          <a:srcRect/>
-          <a:stretch>
-            <a:fillRect/>
-          </a:stretch>
-        </p:blipFill>
-        <p:spPr bwMode="auto">
-          <a:xfrm>
-            <a:off x="3238500" y="4984359"/>
-            <a:ext cx="5715000" cy="2809875"/>
+            <a:r>
+              <a:rPr lang="de-DE"/>
+              <a:t>0</a:t>
+            </a:r>
+          </a:p>
+        </p:txBody>
+      </p:sp>
+      <p:sp>
+        <p:nvSpPr>
+          <p:cNvPr id="1040" name="Textfeld 1039">
+            <a:extLst>
+              <a:ext uri="{FF2B5EF4-FFF2-40B4-BE49-F238E27FC236}">
+                <a16:creationId xmlns:a16="http://schemas.microsoft.com/office/drawing/2014/main" id="{F19212E8-BB7B-CA89-9AB6-23B1E2931B3A}"/>
+              </a:ext>
+            </a:extLst>
+          </p:cNvPr>
+          <p:cNvSpPr txBox="1"/>
+          <p:nvPr/>
+        </p:nvSpPr>
+        <p:spPr>
+          <a:xfrm>
+            <a:off x="3905120" y="5648673"/>
+            <a:ext cx="1083438" cy="338554"/>
           </a:xfrm>
           <a:prstGeom prst="rect">
             <a:avLst/>
           </a:prstGeom>
           <a:noFill/>
-          <a:extLst>
-            <a:ext uri="{909E8E84-426E-40DD-AFC4-6F175D3DCCD1}">
-              <a14:hiddenFill xmlns:a14="http://schemas.microsoft.com/office/drawing/2010/main">
-                <a:solidFill>
-                  <a:srgbClr val="FFFFFF"/>
-                </a:solidFill>
-              </a14:hiddenFill>
-            </a:ext>
-          </a:extLst>
-        </p:spPr>
-      </p:pic>
-      <p:sp>
-        <p:nvSpPr>
-          <p:cNvPr id="63" name="Textfeld 62">
-            <a:extLst>
-              <a:ext uri="{FF2B5EF4-FFF2-40B4-BE49-F238E27FC236}">
-                <a16:creationId xmlns:a16="http://schemas.microsoft.com/office/drawing/2014/main" id="{C31A9BEF-F531-2616-7951-DD70FF313C7A}"/>
-              </a:ext>
-            </a:extLst>
-          </p:cNvPr>
-          <p:cNvSpPr txBox="1"/>
-          <p:nvPr/>
-        </p:nvSpPr>
-        <p:spPr>
-          <a:xfrm>
-            <a:off x="3560441" y="8227667"/>
-            <a:ext cx="6096000" cy="369332"/>
-          </a:xfrm>
-          <a:prstGeom prst="rect">
-            <a:avLst/>
-          </a:prstGeom>
-          <a:noFill/>
-        </p:spPr>
-        <p:txBody>
-          <a:bodyPr wrap="square">
+        </p:spPr>
+        <p:txBody>
+          <a:bodyPr wrap="none" rtlCol="0">
             <a:spAutoFit/>
           </a:bodyPr>
           <a:lstStyle/>
           <a:p>
             <a:r>
-              <a:rPr lang="en-US">
-                <a:hlinkClick r:id="rId3"/>
-              </a:rPr>
-              <a:t>Apache Kafka | Developer Experience Knowledge Base</a:t>
-            </a:r>
+              <a:rPr lang="de-DE" sz="1600"/>
+              <a:t>Partition 1</a:t>
+            </a:r>
+          </a:p>
+        </p:txBody>
+      </p:sp>
+      <p:sp>
+        <p:nvSpPr>
+          <p:cNvPr id="1041" name="Rechteck: abgerundete Ecken 1040">
+            <a:extLst>
+              <a:ext uri="{FF2B5EF4-FFF2-40B4-BE49-F238E27FC236}">
+                <a16:creationId xmlns:a16="http://schemas.microsoft.com/office/drawing/2014/main" id="{9B2FD0A3-CEDB-03E1-84FB-7E30C2329D2B}"/>
+              </a:ext>
+            </a:extLst>
+          </p:cNvPr>
+          <p:cNvSpPr/>
+          <p:nvPr/>
+        </p:nvSpPr>
+        <p:spPr>
+          <a:xfrm>
+            <a:off x="4069301" y="6141148"/>
+            <a:ext cx="755076" cy="589130"/>
+          </a:xfrm>
+          <a:prstGeom prst="roundRect">
+            <a:avLst/>
+          </a:prstGeom>
+        </p:spPr>
+        <p:style>
+          <a:lnRef idx="1">
+            <a:schemeClr val="accent2"/>
+          </a:lnRef>
+          <a:fillRef idx="2">
+            <a:schemeClr val="accent2"/>
+          </a:fillRef>
+          <a:effectRef idx="1">
+            <a:schemeClr val="accent2"/>
+          </a:effectRef>
+          <a:fontRef idx="minor">
+            <a:schemeClr val="dk1"/>
+          </a:fontRef>
+        </p:style>
+        <p:txBody>
+          <a:bodyPr rtlCol="0" anchor="ctr"/>
+          <a:lstStyle/>
+          <a:p>
+            <a:pPr algn="ctr"/>
+            <a:r>
+              <a:rPr lang="de-DE"/>
+              <a:t>1</a:t>
+            </a:r>
+          </a:p>
+        </p:txBody>
+      </p:sp>
+      <p:sp>
+        <p:nvSpPr>
+          <p:cNvPr id="1042" name="Rechteck: abgerundete Ecken 1041">
+            <a:extLst>
+              <a:ext uri="{FF2B5EF4-FFF2-40B4-BE49-F238E27FC236}">
+                <a16:creationId xmlns:a16="http://schemas.microsoft.com/office/drawing/2014/main" id="{F10C5113-B914-9DE7-60C8-16F5B0BBE08F}"/>
+              </a:ext>
+            </a:extLst>
+          </p:cNvPr>
+          <p:cNvSpPr/>
+          <p:nvPr/>
+        </p:nvSpPr>
+        <p:spPr>
+          <a:xfrm>
+            <a:off x="5009840" y="6134424"/>
+            <a:ext cx="755076" cy="589130"/>
+          </a:xfrm>
+          <a:prstGeom prst="roundRect">
+            <a:avLst/>
+          </a:prstGeom>
+        </p:spPr>
+        <p:style>
+          <a:lnRef idx="1">
+            <a:schemeClr val="accent2"/>
+          </a:lnRef>
+          <a:fillRef idx="2">
+            <a:schemeClr val="accent2"/>
+          </a:fillRef>
+          <a:effectRef idx="1">
+            <a:schemeClr val="accent2"/>
+          </a:effectRef>
+          <a:fontRef idx="minor">
+            <a:schemeClr val="dk1"/>
+          </a:fontRef>
+        </p:style>
+        <p:txBody>
+          <a:bodyPr rtlCol="0" anchor="ctr"/>
+          <a:lstStyle/>
+          <a:p>
+            <a:pPr algn="ctr"/>
+            <a:r>
+              <a:rPr lang="de-DE"/>
+              <a:t>2</a:t>
+            </a:r>
+          </a:p>
+        </p:txBody>
+      </p:sp>
+      <p:cxnSp>
+        <p:nvCxnSpPr>
+          <p:cNvPr id="1049" name="Gerade Verbindung mit Pfeil 1048">
+            <a:extLst>
+              <a:ext uri="{FF2B5EF4-FFF2-40B4-BE49-F238E27FC236}">
+                <a16:creationId xmlns:a16="http://schemas.microsoft.com/office/drawing/2014/main" id="{5CB29BD3-0C2B-E5FE-1CC5-7F62A31F8483}"/>
+              </a:ext>
+            </a:extLst>
+          </p:cNvPr>
+          <p:cNvCxnSpPr>
+            <a:cxnSpLocks/>
+            <a:stCxn id="41" idx="2"/>
+            <a:endCxn id="1038" idx="1"/>
+          </p:cNvCxnSpPr>
+          <p:nvPr/>
+        </p:nvCxnSpPr>
+        <p:spPr>
+          <a:xfrm>
+            <a:off x="869017" y="3209105"/>
+            <a:ext cx="1795131" cy="3242254"/>
+          </a:xfrm>
+          <a:prstGeom prst="straightConnector1">
+            <a:avLst/>
+          </a:prstGeom>
+          <a:ln>
+            <a:tailEnd type="triangle"/>
+          </a:ln>
+        </p:spPr>
+        <p:style>
+          <a:lnRef idx="2">
+            <a:schemeClr val="accent1"/>
+          </a:lnRef>
+          <a:fillRef idx="0">
+            <a:schemeClr val="accent1"/>
+          </a:fillRef>
+          <a:effectRef idx="1">
+            <a:schemeClr val="accent1"/>
+          </a:effectRef>
+          <a:fontRef idx="minor">
+            <a:schemeClr val="tx1"/>
+          </a:fontRef>
+        </p:style>
+      </p:cxnSp>
+      <p:sp>
+        <p:nvSpPr>
+          <p:cNvPr id="1051" name="Rechteck: abgerundete Ecken 1050">
+            <a:extLst>
+              <a:ext uri="{FF2B5EF4-FFF2-40B4-BE49-F238E27FC236}">
+                <a16:creationId xmlns:a16="http://schemas.microsoft.com/office/drawing/2014/main" id="{06E27F4C-C66B-3C26-70D6-8C5CC7BDC352}"/>
+              </a:ext>
+            </a:extLst>
+          </p:cNvPr>
+          <p:cNvSpPr/>
+          <p:nvPr/>
+        </p:nvSpPr>
+        <p:spPr>
+          <a:xfrm>
+            <a:off x="1494979" y="4634795"/>
+            <a:ext cx="511469" cy="345394"/>
+          </a:xfrm>
+          <a:prstGeom prst="roundRect">
+            <a:avLst/>
+          </a:prstGeom>
+        </p:spPr>
+        <p:style>
+          <a:lnRef idx="1">
+            <a:schemeClr val="accent2"/>
+          </a:lnRef>
+          <a:fillRef idx="2">
+            <a:schemeClr val="accent2"/>
+          </a:fillRef>
+          <a:effectRef idx="1">
+            <a:schemeClr val="accent2"/>
+          </a:effectRef>
+          <a:fontRef idx="minor">
+            <a:schemeClr val="dk1"/>
+          </a:fontRef>
+        </p:style>
+        <p:txBody>
+          <a:bodyPr rtlCol="0" anchor="ctr"/>
+          <a:lstStyle/>
+          <a:p>
+            <a:pPr algn="ctr"/>
+            <a:endParaRPr lang="de-DE"/>
+          </a:p>
+        </p:txBody>
+      </p:sp>
+      <p:sp>
+        <p:nvSpPr>
+          <p:cNvPr id="1052" name="Rechteck: abgerundete Ecken 1051">
+            <a:extLst>
+              <a:ext uri="{FF2B5EF4-FFF2-40B4-BE49-F238E27FC236}">
+                <a16:creationId xmlns:a16="http://schemas.microsoft.com/office/drawing/2014/main" id="{645C6F20-2CFF-1632-AAB7-2A3B13869995}"/>
+              </a:ext>
+            </a:extLst>
+          </p:cNvPr>
+          <p:cNvSpPr/>
+          <p:nvPr/>
+        </p:nvSpPr>
+        <p:spPr>
+          <a:xfrm>
+            <a:off x="7835303" y="6247167"/>
+            <a:ext cx="1390483" cy="413815"/>
+          </a:xfrm>
+          <a:prstGeom prst="roundRect">
+            <a:avLst/>
+          </a:prstGeom>
+        </p:spPr>
+        <p:style>
+          <a:lnRef idx="1">
+            <a:schemeClr val="accent6"/>
+          </a:lnRef>
+          <a:fillRef idx="2">
+            <a:schemeClr val="accent6"/>
+          </a:fillRef>
+          <a:effectRef idx="1">
+            <a:schemeClr val="accent6"/>
+          </a:effectRef>
+          <a:fontRef idx="minor">
+            <a:schemeClr val="dk1"/>
+          </a:fontRef>
+        </p:style>
+        <p:txBody>
+          <a:bodyPr rtlCol="0" anchor="ctr"/>
+          <a:lstStyle/>
+          <a:p>
+            <a:pPr algn="ctr"/>
+            <a:r>
+              <a:rPr lang="de-DE" b="1"/>
+              <a:t>Consumer</a:t>
+            </a:r>
+            <a:endParaRPr lang="de-DE" sz="1050"/>
+          </a:p>
+        </p:txBody>
+      </p:sp>
+      <p:cxnSp>
+        <p:nvCxnSpPr>
+          <p:cNvPr id="1053" name="Gerade Verbindung mit Pfeil 1052">
+            <a:extLst>
+              <a:ext uri="{FF2B5EF4-FFF2-40B4-BE49-F238E27FC236}">
+                <a16:creationId xmlns:a16="http://schemas.microsoft.com/office/drawing/2014/main" id="{6AEF6130-1C52-6594-7C82-FC9B57DC12AA}"/>
+              </a:ext>
+            </a:extLst>
+          </p:cNvPr>
+          <p:cNvCxnSpPr>
+            <a:cxnSpLocks/>
+            <a:stCxn id="1038" idx="3"/>
+            <a:endCxn id="1052" idx="1"/>
+          </p:cNvCxnSpPr>
+          <p:nvPr/>
+        </p:nvCxnSpPr>
+        <p:spPr>
+          <a:xfrm>
+            <a:off x="6286867" y="6451359"/>
+            <a:ext cx="1548436" cy="2716"/>
+          </a:xfrm>
+          <a:prstGeom prst="straightConnector1">
+            <a:avLst/>
+          </a:prstGeom>
+          <a:ln>
+            <a:tailEnd type="triangle"/>
+          </a:ln>
+        </p:spPr>
+        <p:style>
+          <a:lnRef idx="2">
+            <a:schemeClr val="accent1"/>
+          </a:lnRef>
+          <a:fillRef idx="0">
+            <a:schemeClr val="accent1"/>
+          </a:fillRef>
+          <a:effectRef idx="1">
+            <a:schemeClr val="accent1"/>
+          </a:effectRef>
+          <a:fontRef idx="minor">
+            <a:schemeClr val="tx1"/>
+          </a:fontRef>
+        </p:style>
+      </p:cxnSp>
+      <p:sp>
+        <p:nvSpPr>
+          <p:cNvPr id="1057" name="Rechteck: abgerundete Ecken 1056">
+            <a:extLst>
+              <a:ext uri="{FF2B5EF4-FFF2-40B4-BE49-F238E27FC236}">
+                <a16:creationId xmlns:a16="http://schemas.microsoft.com/office/drawing/2014/main" id="{3A6095D2-2992-BDCA-37D4-11417AD37488}"/>
+              </a:ext>
+            </a:extLst>
+          </p:cNvPr>
+          <p:cNvSpPr/>
+          <p:nvPr/>
+        </p:nvSpPr>
+        <p:spPr>
+          <a:xfrm>
+            <a:off x="6903299" y="6278662"/>
+            <a:ext cx="511469" cy="345394"/>
+          </a:xfrm>
+          <a:prstGeom prst="roundRect">
+            <a:avLst/>
+          </a:prstGeom>
+        </p:spPr>
+        <p:style>
+          <a:lnRef idx="1">
+            <a:schemeClr val="accent2"/>
+          </a:lnRef>
+          <a:fillRef idx="2">
+            <a:schemeClr val="accent2"/>
+          </a:fillRef>
+          <a:effectRef idx="1">
+            <a:schemeClr val="accent2"/>
+          </a:effectRef>
+          <a:fontRef idx="minor">
+            <a:schemeClr val="dk1"/>
+          </a:fontRef>
+        </p:style>
+        <p:txBody>
+          <a:bodyPr rtlCol="0" anchor="ctr"/>
+          <a:lstStyle/>
+          <a:p>
+            <a:pPr algn="ctr"/>
+            <a:endParaRPr lang="de-DE"/>
+          </a:p>
+        </p:txBody>
+      </p:sp>
+      <p:sp>
+        <p:nvSpPr>
+          <p:cNvPr id="1059" name="Textfeld 1058">
+            <a:extLst>
+              <a:ext uri="{FF2B5EF4-FFF2-40B4-BE49-F238E27FC236}">
+                <a16:creationId xmlns:a16="http://schemas.microsoft.com/office/drawing/2014/main" id="{2A224DAB-BFCD-72A0-99EF-8BADC6343F4A}"/>
+              </a:ext>
+            </a:extLst>
+          </p:cNvPr>
+          <p:cNvSpPr txBox="1"/>
+          <p:nvPr/>
+        </p:nvSpPr>
+        <p:spPr>
+          <a:xfrm>
+            <a:off x="7695589" y="478134"/>
+            <a:ext cx="2105705" cy="369332"/>
+          </a:xfrm>
+          <a:prstGeom prst="rect">
+            <a:avLst/>
+          </a:prstGeom>
+          <a:noFill/>
+        </p:spPr>
+        <p:txBody>
+          <a:bodyPr wrap="none" rtlCol="0">
+            <a:spAutoFit/>
+          </a:bodyPr>
+          <a:lstStyle/>
+          <a:p>
+            <a:r>
+              <a:rPr lang="de-DE" b="1"/>
+              <a:t>Consumer group 1</a:t>
+            </a:r>
+          </a:p>
+        </p:txBody>
+      </p:sp>
+      <p:sp>
+        <p:nvSpPr>
+          <p:cNvPr id="1061" name="Textfeld 1060">
+            <a:extLst>
+              <a:ext uri="{FF2B5EF4-FFF2-40B4-BE49-F238E27FC236}">
+                <a16:creationId xmlns:a16="http://schemas.microsoft.com/office/drawing/2014/main" id="{693A05B7-E379-D9BA-E1FC-A033131D6B98}"/>
+              </a:ext>
+            </a:extLst>
+          </p:cNvPr>
+          <p:cNvSpPr txBox="1"/>
+          <p:nvPr/>
+        </p:nvSpPr>
+        <p:spPr>
+          <a:xfrm>
+            <a:off x="7708362" y="5261330"/>
+            <a:ext cx="2105705" cy="369332"/>
+          </a:xfrm>
+          <a:prstGeom prst="rect">
+            <a:avLst/>
+          </a:prstGeom>
+          <a:noFill/>
+        </p:spPr>
+        <p:txBody>
+          <a:bodyPr wrap="none" rtlCol="0">
+            <a:spAutoFit/>
+          </a:bodyPr>
+          <a:lstStyle/>
+          <a:p>
+            <a:r>
+              <a:rPr lang="de-DE" b="1"/>
+              <a:t>Consumer group 2</a:t>
+            </a:r>
+          </a:p>
+        </p:txBody>
+      </p:sp>
+      <p:cxnSp>
+        <p:nvCxnSpPr>
+          <p:cNvPr id="1062" name="Gerade Verbindung mit Pfeil 1061">
+            <a:extLst>
+              <a:ext uri="{FF2B5EF4-FFF2-40B4-BE49-F238E27FC236}">
+                <a16:creationId xmlns:a16="http://schemas.microsoft.com/office/drawing/2014/main" id="{66140E26-8DA4-E5D7-75A7-8BCD4D75B137}"/>
+              </a:ext>
+            </a:extLst>
+          </p:cNvPr>
+          <p:cNvCxnSpPr>
+            <a:cxnSpLocks/>
+          </p:cNvCxnSpPr>
+          <p:nvPr/>
+        </p:nvCxnSpPr>
+        <p:spPr>
+          <a:xfrm>
+            <a:off x="6455509" y="4447359"/>
+            <a:ext cx="1341865" cy="1964163"/>
+          </a:xfrm>
+          <a:prstGeom prst="straightConnector1">
+            <a:avLst/>
+          </a:prstGeom>
+          <a:ln>
+            <a:tailEnd type="triangle"/>
+          </a:ln>
+        </p:spPr>
+        <p:style>
+          <a:lnRef idx="2">
+            <a:schemeClr val="accent1"/>
+          </a:lnRef>
+          <a:fillRef idx="0">
+            <a:schemeClr val="accent1"/>
+          </a:fillRef>
+          <a:effectRef idx="1">
+            <a:schemeClr val="accent1"/>
+          </a:effectRef>
+          <a:fontRef idx="minor">
+            <a:schemeClr val="tx1"/>
+          </a:fontRef>
+        </p:style>
+      </p:cxnSp>
+      <p:sp>
+        <p:nvSpPr>
+          <p:cNvPr id="1066" name="Rechteck: abgerundete Ecken 1065">
+            <a:extLst>
+              <a:ext uri="{FF2B5EF4-FFF2-40B4-BE49-F238E27FC236}">
+                <a16:creationId xmlns:a16="http://schemas.microsoft.com/office/drawing/2014/main" id="{B071CBB5-BFC2-1098-2264-632300273AC1}"/>
+              </a:ext>
+            </a:extLst>
+          </p:cNvPr>
+          <p:cNvSpPr/>
+          <p:nvPr/>
+        </p:nvSpPr>
+        <p:spPr>
+          <a:xfrm>
+            <a:off x="6888406" y="5017946"/>
+            <a:ext cx="511469" cy="345394"/>
+          </a:xfrm>
+          <a:prstGeom prst="roundRect">
+            <a:avLst/>
+          </a:prstGeom>
+        </p:spPr>
+        <p:style>
+          <a:lnRef idx="1">
+            <a:schemeClr val="accent5"/>
+          </a:lnRef>
+          <a:fillRef idx="2">
+            <a:schemeClr val="accent5"/>
+          </a:fillRef>
+          <a:effectRef idx="1">
+            <a:schemeClr val="accent5"/>
+          </a:effectRef>
+          <a:fontRef idx="minor">
+            <a:schemeClr val="dk1"/>
+          </a:fontRef>
+        </p:style>
+        <p:txBody>
+          <a:bodyPr rtlCol="0" anchor="ctr"/>
+          <a:lstStyle/>
+          <a:p>
+            <a:pPr algn="ctr"/>
             <a:endParaRPr lang="de-DE"/>
           </a:p>
         </p:txBody>

</xml_diff>